<commit_message>
Update templates, add PDF, tidy summary script
Updated the PowerPoint and Word templates (Final_Makale_Sunum_Sablonu.pptx, Final_Odevi_Makale_Sablonu.docx). Added a PDF export (Final_Odevi_Makale_Sablonu.pdf) and removed a temporary Office file (~$nal_Odevi_Makale_Sablonu.docx). Minor cleanup in summarize_overall_report.py: removed an extra blank line, consolidated the per-model print into a single f-string expression (no functional change), and ensured a newline at EOF.
</commit_message>
<xml_diff>
--- a/Final_Makale_Sunum_Sablonu.pptx
+++ b/Final_Makale_Sunum_Sablonu.pptx
@@ -5,7 +5,7 @@
     <p:sldMasterId id="2147483648" r:id="rId1"/>
   </p:sldMasterIdLst>
   <p:notesMasterIdLst>
-    <p:notesMasterId r:id="rId12"/>
+    <p:notesMasterId r:id="rId14"/>
   </p:notesMasterIdLst>
   <p:sldIdLst>
     <p:sldId id="256" r:id="rId2"/>
@@ -14,10 +14,12 @@
     <p:sldId id="259" r:id="rId5"/>
     <p:sldId id="260" r:id="rId6"/>
     <p:sldId id="261" r:id="rId7"/>
-    <p:sldId id="262" r:id="rId8"/>
-    <p:sldId id="263" r:id="rId9"/>
-    <p:sldId id="264" r:id="rId10"/>
-    <p:sldId id="265" r:id="rId11"/>
+    <p:sldId id="267" r:id="rId8"/>
+    <p:sldId id="268" r:id="rId9"/>
+    <p:sldId id="262" r:id="rId10"/>
+    <p:sldId id="263" r:id="rId11"/>
+    <p:sldId id="264" r:id="rId12"/>
+    <p:sldId id="265" r:id="rId13"/>
   </p:sldIdLst>
   <p:sldSz cx="12192000" cy="6858000"/>
   <p:notesSz cx="6858000" cy="12192000"/>
@@ -414,6 +416,174 @@
 </p:notes>
 </file>
 
+<file path=ppt/notesSlides/notesSlide11.xml><?xml version="1.0" encoding="utf-8"?>
+<p:notes xmlns:a="http://schemas.openxmlformats.org/drawingml/2006/main" xmlns:r="http://schemas.openxmlformats.org/officeDocument/2006/relationships" xmlns:p="http://schemas.openxmlformats.org/presentationml/2006/main">
+  <p:cSld>
+    <p:spTree>
+      <p:nvGrpSpPr>
+        <p:cNvPr id="1" name=""/>
+        <p:cNvGrpSpPr/>
+        <p:nvPr/>
+      </p:nvGrpSpPr>
+      <p:grpSpPr>
+        <a:xfrm>
+          <a:off x="0" y="0"/>
+          <a:ext cx="0" cy="0"/>
+          <a:chOff x="0" y="0"/>
+          <a:chExt cx="0" cy="0"/>
+        </a:xfrm>
+      </p:grpSpPr>
+      <p:sp>
+        <p:nvSpPr>
+          <p:cNvPr id="2" name="Slide Image Placeholder 1"/>
+          <p:cNvSpPr>
+            <a:spLocks noGrp="1" noRot="1" noChangeAspect="1"/>
+          </p:cNvSpPr>
+          <p:nvPr>
+            <p:ph type="sldImg"/>
+          </p:nvPr>
+        </p:nvSpPr>
+        <p:spPr/>
+      </p:sp>
+      <p:sp>
+        <p:nvSpPr>
+          <p:cNvPr id="3" name="Notes Placeholder 2"/>
+          <p:cNvSpPr>
+            <a:spLocks noGrp="1"/>
+          </p:cNvSpPr>
+          <p:nvPr>
+            <p:ph type="body" idx="1"/>
+          </p:nvPr>
+        </p:nvSpPr>
+        <p:spPr/>
+        <p:txBody>
+          <a:bodyPr/>
+          <a:lstStyle/>
+          <a:p>
+            <a:endParaRPr lang="en-US" dirty="0"/>
+          </a:p>
+        </p:txBody>
+      </p:sp>
+      <p:sp>
+        <p:nvSpPr>
+          <p:cNvPr id="4" name="Slide Number Placeholder 3"/>
+          <p:cNvSpPr>
+            <a:spLocks noGrp="1"/>
+          </p:cNvSpPr>
+          <p:nvPr>
+            <p:ph type="sldNum" sz="quarter" idx="10"/>
+          </p:nvPr>
+        </p:nvSpPr>
+        <p:spPr/>
+        <p:txBody>
+          <a:bodyPr/>
+          <a:lstStyle/>
+          <a:p>
+            <a:fld id="{F7021451-1387-4CA6-816F-3879F97B5CBC}" type="slidenum">
+              <a:rPr lang="en-US"/>
+              <a:t>11</a:t>
+            </a:fld>
+            <a:endParaRPr lang="en-US"/>
+          </a:p>
+        </p:txBody>
+      </p:sp>
+    </p:spTree>
+    <p:extLst>
+      <p:ext uri="{BB962C8B-B14F-4D97-AF65-F5344CB8AC3E}">
+        <p14:creationId xmlns:p14="http://schemas.microsoft.com/office/powerpoint/2010/main" val="1024086991"/>
+      </p:ext>
+    </p:extLst>
+  </p:cSld>
+  <p:clrMapOvr>
+    <a:masterClrMapping/>
+  </p:clrMapOvr>
+</p:notes>
+</file>
+
+<file path=ppt/notesSlides/notesSlide12.xml><?xml version="1.0" encoding="utf-8"?>
+<p:notes xmlns:a="http://schemas.openxmlformats.org/drawingml/2006/main" xmlns:r="http://schemas.openxmlformats.org/officeDocument/2006/relationships" xmlns:p="http://schemas.openxmlformats.org/presentationml/2006/main">
+  <p:cSld>
+    <p:spTree>
+      <p:nvGrpSpPr>
+        <p:cNvPr id="1" name=""/>
+        <p:cNvGrpSpPr/>
+        <p:nvPr/>
+      </p:nvGrpSpPr>
+      <p:grpSpPr>
+        <a:xfrm>
+          <a:off x="0" y="0"/>
+          <a:ext cx="0" cy="0"/>
+          <a:chOff x="0" y="0"/>
+          <a:chExt cx="0" cy="0"/>
+        </a:xfrm>
+      </p:grpSpPr>
+      <p:sp>
+        <p:nvSpPr>
+          <p:cNvPr id="2" name="Slide Image Placeholder 1"/>
+          <p:cNvSpPr>
+            <a:spLocks noGrp="1" noRot="1" noChangeAspect="1"/>
+          </p:cNvSpPr>
+          <p:nvPr>
+            <p:ph type="sldImg"/>
+          </p:nvPr>
+        </p:nvSpPr>
+        <p:spPr/>
+      </p:sp>
+      <p:sp>
+        <p:nvSpPr>
+          <p:cNvPr id="3" name="Notes Placeholder 2"/>
+          <p:cNvSpPr>
+            <a:spLocks noGrp="1"/>
+          </p:cNvSpPr>
+          <p:nvPr>
+            <p:ph type="body" idx="1"/>
+          </p:nvPr>
+        </p:nvSpPr>
+        <p:spPr/>
+        <p:txBody>
+          <a:bodyPr/>
+          <a:lstStyle/>
+          <a:p>
+            <a:endParaRPr lang="en-US" dirty="0"/>
+          </a:p>
+        </p:txBody>
+      </p:sp>
+      <p:sp>
+        <p:nvSpPr>
+          <p:cNvPr id="4" name="Slide Number Placeholder 3"/>
+          <p:cNvSpPr>
+            <a:spLocks noGrp="1"/>
+          </p:cNvSpPr>
+          <p:nvPr>
+            <p:ph type="sldNum" sz="quarter" idx="10"/>
+          </p:nvPr>
+        </p:nvSpPr>
+        <p:spPr/>
+        <p:txBody>
+          <a:bodyPr/>
+          <a:lstStyle/>
+          <a:p>
+            <a:fld id="{F7021451-1387-4CA6-816F-3879F97B5CBC}" type="slidenum">
+              <a:rPr lang="en-US"/>
+              <a:t>12</a:t>
+            </a:fld>
+            <a:endParaRPr lang="en-US"/>
+          </a:p>
+        </p:txBody>
+      </p:sp>
+    </p:spTree>
+    <p:extLst>
+      <p:ext uri="{BB962C8B-B14F-4D97-AF65-F5344CB8AC3E}">
+        <p14:creationId xmlns:p14="http://schemas.microsoft.com/office/powerpoint/2010/main" val="1024086991"/>
+      </p:ext>
+    </p:extLst>
+  </p:cSld>
+  <p:clrMapOvr>
+    <a:masterClrMapping/>
+  </p:clrMapOvr>
+</p:notes>
+</file>
+
 <file path=ppt/notesSlides/notesSlide2.xml><?xml version="1.0" encoding="utf-8"?>
 <p:notes xmlns:a="http://schemas.openxmlformats.org/drawingml/2006/main" xmlns:r="http://schemas.openxmlformats.org/officeDocument/2006/relationships" xmlns:p="http://schemas.openxmlformats.org/presentationml/2006/main">
   <p:cSld>
@@ -839,7 +1009,13 @@
   <p:cSld>
     <p:spTree>
       <p:nvGrpSpPr>
-        <p:cNvPr id="1" name=""/>
+        <p:cNvPr id="1" name="">
+          <a:extLst>
+            <a:ext uri="{FF2B5EF4-FFF2-40B4-BE49-F238E27FC236}">
+              <a16:creationId xmlns:a16="http://schemas.microsoft.com/office/drawing/2014/main" id="{57F45D1E-85D5-6959-5F3F-B1B07C6F0354}"/>
+            </a:ext>
+          </a:extLst>
+        </p:cNvPr>
         <p:cNvGrpSpPr/>
         <p:nvPr/>
       </p:nvGrpSpPr>
@@ -853,7 +1029,13 @@
       </p:grpSpPr>
       <p:sp>
         <p:nvSpPr>
-          <p:cNvPr id="2" name="Slide Image Placeholder 1"/>
+          <p:cNvPr id="2" name="Slide Image Placeholder 1">
+            <a:extLst>
+              <a:ext uri="{FF2B5EF4-FFF2-40B4-BE49-F238E27FC236}">
+                <a16:creationId xmlns:a16="http://schemas.microsoft.com/office/drawing/2014/main" id="{A7C79A9B-E3BB-2140-9124-2250968EE587}"/>
+              </a:ext>
+            </a:extLst>
+          </p:cNvPr>
           <p:cNvSpPr>
             <a:spLocks noGrp="1" noRot="1" noChangeAspect="1"/>
           </p:cNvSpPr>
@@ -865,7 +1047,13 @@
       </p:sp>
       <p:sp>
         <p:nvSpPr>
-          <p:cNvPr id="3" name="Notes Placeholder 2"/>
+          <p:cNvPr id="3" name="Notes Placeholder 2">
+            <a:extLst>
+              <a:ext uri="{FF2B5EF4-FFF2-40B4-BE49-F238E27FC236}">
+                <a16:creationId xmlns:a16="http://schemas.microsoft.com/office/drawing/2014/main" id="{05F10BBB-EADE-6D5A-98DC-8F474F67E02B}"/>
+              </a:ext>
+            </a:extLst>
+          </p:cNvPr>
           <p:cNvSpPr>
             <a:spLocks noGrp="1"/>
           </p:cNvSpPr>
@@ -884,7 +1072,13 @@
       </p:sp>
       <p:sp>
         <p:nvSpPr>
-          <p:cNvPr id="4" name="Slide Number Placeholder 3"/>
+          <p:cNvPr id="4" name="Slide Number Placeholder 3">
+            <a:extLst>
+              <a:ext uri="{FF2B5EF4-FFF2-40B4-BE49-F238E27FC236}">
+                <a16:creationId xmlns:a16="http://schemas.microsoft.com/office/drawing/2014/main" id="{31EC5613-E46D-8DD9-2934-B67550A9DBAF}"/>
+              </a:ext>
+            </a:extLst>
+          </p:cNvPr>
           <p:cNvSpPr>
             <a:spLocks noGrp="1"/>
           </p:cNvSpPr>
@@ -908,7 +1102,7 @@
     </p:spTree>
     <p:extLst>
       <p:ext uri="{BB962C8B-B14F-4D97-AF65-F5344CB8AC3E}">
-        <p14:creationId xmlns:p14="http://schemas.microsoft.com/office/powerpoint/2010/main" val="1024086991"/>
+        <p14:creationId xmlns:p14="http://schemas.microsoft.com/office/powerpoint/2010/main" val="2326265697"/>
       </p:ext>
     </p:extLst>
   </p:cSld>
@@ -923,7 +1117,13 @@
   <p:cSld>
     <p:spTree>
       <p:nvGrpSpPr>
-        <p:cNvPr id="1" name=""/>
+        <p:cNvPr id="1" name="">
+          <a:extLst>
+            <a:ext uri="{FF2B5EF4-FFF2-40B4-BE49-F238E27FC236}">
+              <a16:creationId xmlns:a16="http://schemas.microsoft.com/office/drawing/2014/main" id="{09620E6E-86E2-374B-205B-B72AB2DFB211}"/>
+            </a:ext>
+          </a:extLst>
+        </p:cNvPr>
         <p:cNvGrpSpPr/>
         <p:nvPr/>
       </p:nvGrpSpPr>
@@ -937,7 +1137,13 @@
       </p:grpSpPr>
       <p:sp>
         <p:nvSpPr>
-          <p:cNvPr id="2" name="Slide Image Placeholder 1"/>
+          <p:cNvPr id="2" name="Slide Image Placeholder 1">
+            <a:extLst>
+              <a:ext uri="{FF2B5EF4-FFF2-40B4-BE49-F238E27FC236}">
+                <a16:creationId xmlns:a16="http://schemas.microsoft.com/office/drawing/2014/main" id="{2CD490B8-6CC1-5857-8C3C-ED496E4405C0}"/>
+              </a:ext>
+            </a:extLst>
+          </p:cNvPr>
           <p:cNvSpPr>
             <a:spLocks noGrp="1" noRot="1" noChangeAspect="1"/>
           </p:cNvSpPr>
@@ -949,7 +1155,13 @@
       </p:sp>
       <p:sp>
         <p:nvSpPr>
-          <p:cNvPr id="3" name="Notes Placeholder 2"/>
+          <p:cNvPr id="3" name="Notes Placeholder 2">
+            <a:extLst>
+              <a:ext uri="{FF2B5EF4-FFF2-40B4-BE49-F238E27FC236}">
+                <a16:creationId xmlns:a16="http://schemas.microsoft.com/office/drawing/2014/main" id="{6BA5414B-54C6-A126-8E6B-3CC9D197DAA3}"/>
+              </a:ext>
+            </a:extLst>
+          </p:cNvPr>
           <p:cNvSpPr>
             <a:spLocks noGrp="1"/>
           </p:cNvSpPr>
@@ -968,7 +1180,13 @@
       </p:sp>
       <p:sp>
         <p:nvSpPr>
-          <p:cNvPr id="4" name="Slide Number Placeholder 3"/>
+          <p:cNvPr id="4" name="Slide Number Placeholder 3">
+            <a:extLst>
+              <a:ext uri="{FF2B5EF4-FFF2-40B4-BE49-F238E27FC236}">
+                <a16:creationId xmlns:a16="http://schemas.microsoft.com/office/drawing/2014/main" id="{BE71CD17-DB86-A641-5312-37008A49B6FB}"/>
+              </a:ext>
+            </a:extLst>
+          </p:cNvPr>
           <p:cNvSpPr>
             <a:spLocks noGrp="1"/>
           </p:cNvSpPr>
@@ -992,7 +1210,7 @@
     </p:spTree>
     <p:extLst>
       <p:ext uri="{BB962C8B-B14F-4D97-AF65-F5344CB8AC3E}">
-        <p14:creationId xmlns:p14="http://schemas.microsoft.com/office/powerpoint/2010/main" val="1024086991"/>
+        <p14:creationId xmlns:p14="http://schemas.microsoft.com/office/powerpoint/2010/main" val="1654970390"/>
       </p:ext>
     </p:extLst>
   </p:cSld>
@@ -1803,9 +2021,6 @@
           <a:bodyPr wrap="square" lIns="0" tIns="0" rIns="0" bIns="0" rtlCol="0" anchor="ctr"/>
           <a:lstStyle/>
           <a:p>
-            <a:pPr marL="0" indent="0">
-              <a:buNone/>
-            </a:pPr>
             <a:r>
               <a:rPr lang="en-US" sz="850" dirty="0">
                 <a:solidFill>
@@ -1815,7 +2030,18 @@
                 <a:ea typeface="Aptos" pitchFamily="34" charset="-122"/>
                 <a:cs typeface="Aptos" pitchFamily="34" charset="-120"/>
               </a:rPr>
-              <a:t>Final Makale/Bildiri Sunumu  •  1/10</a:t>
+              <a:t>Final Makale/Bildiri Sunumu  •  1 /1</a:t>
+            </a:r>
+            <a:r>
+              <a:rPr lang="tr-TR" sz="850" dirty="0">
+                <a:solidFill>
+                  <a:srgbClr val="6B7280"/>
+                </a:solidFill>
+                <a:latin typeface="Aptos" pitchFamily="34" charset="0"/>
+                <a:ea typeface="Aptos" pitchFamily="34" charset="-122"/>
+                <a:cs typeface="Aptos" pitchFamily="34" charset="-120"/>
+              </a:rPr>
+              <a:t>2</a:t>
             </a:r>
             <a:endParaRPr lang="en-US" sz="850" dirty="0"/>
           </a:p>
@@ -1869,6 +2095,965 @@
 </file>
 
 <file path=ppt/slides/slide10.xml><?xml version="1.0" encoding="utf-8"?>
+<p:sld xmlns:a="http://schemas.openxmlformats.org/drawingml/2006/main" xmlns:r="http://schemas.openxmlformats.org/officeDocument/2006/relationships" xmlns:p="http://schemas.openxmlformats.org/presentationml/2006/main">
+  <p:cSld name="Slide 8">
+    <p:bg>
+      <p:bgPr>
+        <a:solidFill>
+          <a:srgbClr val="F8FAFC"/>
+        </a:solidFill>
+        <a:effectLst/>
+      </p:bgPr>
+    </p:bg>
+    <p:spTree>
+      <p:nvGrpSpPr>
+        <p:cNvPr id="1" name=""/>
+        <p:cNvGrpSpPr/>
+        <p:nvPr/>
+      </p:nvGrpSpPr>
+      <p:grpSpPr>
+        <a:xfrm>
+          <a:off x="0" y="0"/>
+          <a:ext cx="0" cy="0"/>
+          <a:chOff x="0" y="0"/>
+          <a:chExt cx="0" cy="0"/>
+        </a:xfrm>
+      </p:grpSpPr>
+      <p:sp>
+        <p:nvSpPr>
+          <p:cNvPr id="2" name="Shape 0"/>
+          <p:cNvSpPr/>
+          <p:nvPr/>
+        </p:nvSpPr>
+        <p:spPr>
+          <a:xfrm>
+            <a:off x="0" y="0"/>
+            <a:ext cx="12191695" cy="146304"/>
+          </a:xfrm>
+          <a:prstGeom prst="rect">
+            <a:avLst/>
+          </a:prstGeom>
+          <a:solidFill>
+            <a:srgbClr val="1E2A5A"/>
+          </a:solidFill>
+          <a:ln w="12700">
+            <a:solidFill>
+              <a:srgbClr val="1E2A5A"/>
+            </a:solidFill>
+            <a:prstDash val="solid"/>
+          </a:ln>
+        </p:spPr>
+        <p:txBody>
+          <a:bodyPr/>
+          <a:lstStyle/>
+          <a:p>
+            <a:endParaRPr lang="tr-TR"/>
+          </a:p>
+        </p:txBody>
+      </p:sp>
+      <p:sp>
+        <p:nvSpPr>
+          <p:cNvPr id="3" name="Text 1"/>
+          <p:cNvSpPr/>
+          <p:nvPr/>
+        </p:nvSpPr>
+        <p:spPr>
+          <a:xfrm>
+            <a:off x="594360" y="438912"/>
+            <a:ext cx="8138160" cy="384048"/>
+          </a:xfrm>
+          <a:prstGeom prst="rect">
+            <a:avLst/>
+          </a:prstGeom>
+          <a:noFill/>
+          <a:ln/>
+        </p:spPr>
+        <p:txBody>
+          <a:bodyPr wrap="square" lIns="0" tIns="0" rIns="0" bIns="0" rtlCol="0" anchor="ctr"/>
+          <a:lstStyle/>
+          <a:p>
+            <a:pPr marL="0" indent="0">
+              <a:buNone/>
+            </a:pPr>
+            <a:r>
+              <a:rPr lang="tr-TR" sz="2400" b="1" dirty="0">
+                <a:solidFill>
+                  <a:srgbClr val="1E2A5A"/>
+                </a:solidFill>
+                <a:latin typeface="Aptos Display" pitchFamily="34" charset="0"/>
+                <a:ea typeface="Aptos Display" pitchFamily="34" charset="-122"/>
+                <a:cs typeface="Aptos Display" pitchFamily="34" charset="-120"/>
+              </a:rPr>
+              <a:t>9</a:t>
+            </a:r>
+            <a:r>
+              <a:rPr lang="en-US" sz="2400" b="1" dirty="0">
+                <a:solidFill>
+                  <a:srgbClr val="1E2A5A"/>
+                </a:solidFill>
+                <a:latin typeface="Aptos Display" pitchFamily="34" charset="0"/>
+                <a:ea typeface="Aptos Display" pitchFamily="34" charset="-122"/>
+                <a:cs typeface="Aptos Display" pitchFamily="34" charset="-120"/>
+              </a:rPr>
+              <a:t>. Literatürle İlişki</a:t>
+            </a:r>
+            <a:endParaRPr lang="en-US" sz="2400" dirty="0"/>
+          </a:p>
+        </p:txBody>
+      </p:sp>
+      <p:sp>
+        <p:nvSpPr>
+          <p:cNvPr id="4" name="Text 2"/>
+          <p:cNvSpPr/>
+          <p:nvPr/>
+        </p:nvSpPr>
+        <p:spPr>
+          <a:xfrm>
+            <a:off x="612648" y="896112"/>
+            <a:ext cx="9966960" cy="256032"/>
+          </a:xfrm>
+          <a:prstGeom prst="rect">
+            <a:avLst/>
+          </a:prstGeom>
+          <a:noFill/>
+          <a:ln/>
+        </p:spPr>
+        <p:txBody>
+          <a:bodyPr wrap="square" lIns="0" tIns="0" rIns="0" bIns="0" rtlCol="0" anchor="ctr"/>
+          <a:lstStyle/>
+          <a:p>
+            <a:pPr marL="0" indent="0">
+              <a:buNone/>
+            </a:pPr>
+            <a:r>
+              <a:rPr lang="en-US" sz="1050" i="1" dirty="0">
+                <a:solidFill>
+                  <a:srgbClr val="6B7280"/>
+                </a:solidFill>
+                <a:latin typeface="Aptos" pitchFamily="34" charset="0"/>
+                <a:ea typeface="Aptos" pitchFamily="34" charset="-122"/>
+                <a:cs typeface="Aptos" pitchFamily="34" charset="-120"/>
+              </a:rPr>
+              <a:t>Kendi sonucunuzu literatür içinde konumlandırın.</a:t>
+            </a:r>
+            <a:endParaRPr lang="en-US" sz="1050" dirty="0"/>
+          </a:p>
+        </p:txBody>
+      </p:sp>
+      <p:sp>
+        <p:nvSpPr>
+          <p:cNvPr id="5" name="Shape 3"/>
+          <p:cNvSpPr/>
+          <p:nvPr/>
+        </p:nvSpPr>
+        <p:spPr>
+          <a:xfrm>
+            <a:off x="594360" y="1261872"/>
+            <a:ext cx="10972800" cy="0"/>
+          </a:xfrm>
+          <a:prstGeom prst="line">
+            <a:avLst/>
+          </a:prstGeom>
+          <a:noFill/>
+          <a:ln w="9525">
+            <a:solidFill>
+              <a:srgbClr val="CBD5E1"/>
+            </a:solidFill>
+            <a:prstDash val="solid"/>
+          </a:ln>
+        </p:spPr>
+        <p:txBody>
+          <a:bodyPr/>
+          <a:lstStyle/>
+          <a:p>
+            <a:endParaRPr lang="tr-TR"/>
+          </a:p>
+        </p:txBody>
+      </p:sp>
+      <p:sp>
+        <p:nvSpPr>
+          <p:cNvPr id="6" name="Text 4"/>
+          <p:cNvSpPr/>
+          <p:nvPr/>
+        </p:nvSpPr>
+        <p:spPr>
+          <a:xfrm>
+            <a:off x="594360" y="6510528"/>
+            <a:ext cx="5029200" cy="201168"/>
+          </a:xfrm>
+          <a:prstGeom prst="rect">
+            <a:avLst/>
+          </a:prstGeom>
+          <a:noFill/>
+          <a:ln/>
+        </p:spPr>
+        <p:txBody>
+          <a:bodyPr wrap="square" lIns="0" tIns="0" rIns="0" bIns="0" rtlCol="0" anchor="ctr"/>
+          <a:lstStyle/>
+          <a:p>
+            <a:r>
+              <a:rPr lang="en-US" sz="850" dirty="0">
+                <a:solidFill>
+                  <a:srgbClr val="6B7280"/>
+                </a:solidFill>
+                <a:latin typeface="Aptos" pitchFamily="34" charset="0"/>
+                <a:ea typeface="Aptos" pitchFamily="34" charset="-122"/>
+                <a:cs typeface="Aptos" pitchFamily="34" charset="-120"/>
+              </a:rPr>
+              <a:t>Final Makale/Bildiri Sunumu  •  </a:t>
+            </a:r>
+            <a:r>
+              <a:rPr lang="tr-TR" sz="850" dirty="0">
+                <a:solidFill>
+                  <a:srgbClr val="6B7280"/>
+                </a:solidFill>
+                <a:latin typeface="Aptos" pitchFamily="34" charset="0"/>
+                <a:ea typeface="Aptos" pitchFamily="34" charset="-122"/>
+                <a:cs typeface="Aptos" pitchFamily="34" charset="-120"/>
+              </a:rPr>
+              <a:t>10</a:t>
+            </a:r>
+            <a:r>
+              <a:rPr lang="en-US" sz="850" dirty="0">
+                <a:solidFill>
+                  <a:srgbClr val="6B7280"/>
+                </a:solidFill>
+                <a:latin typeface="Aptos" pitchFamily="34" charset="0"/>
+                <a:ea typeface="Aptos" pitchFamily="34" charset="-122"/>
+                <a:cs typeface="Aptos" pitchFamily="34" charset="-120"/>
+              </a:rPr>
+              <a:t> /1</a:t>
+            </a:r>
+            <a:r>
+              <a:rPr lang="tr-TR" sz="850" dirty="0">
+                <a:solidFill>
+                  <a:srgbClr val="6B7280"/>
+                </a:solidFill>
+                <a:latin typeface="Aptos" pitchFamily="34" charset="0"/>
+                <a:ea typeface="Aptos" pitchFamily="34" charset="-122"/>
+                <a:cs typeface="Aptos" pitchFamily="34" charset="-120"/>
+              </a:rPr>
+              <a:t>2</a:t>
+            </a:r>
+            <a:endParaRPr lang="en-US" sz="850" dirty="0"/>
+          </a:p>
+        </p:txBody>
+      </p:sp>
+      <p:sp>
+        <p:nvSpPr>
+          <p:cNvPr id="7" name="Text 5"/>
+          <p:cNvSpPr/>
+          <p:nvPr/>
+        </p:nvSpPr>
+        <p:spPr>
+          <a:xfrm>
+            <a:off x="6995160" y="6510528"/>
+            <a:ext cx="4572000" cy="201168"/>
+          </a:xfrm>
+          <a:prstGeom prst="rect">
+            <a:avLst/>
+          </a:prstGeom>
+          <a:noFill/>
+          <a:ln/>
+        </p:spPr>
+        <p:txBody>
+          <a:bodyPr wrap="square" lIns="0" tIns="0" rIns="0" bIns="0" rtlCol="0" anchor="ctr"/>
+          <a:lstStyle/>
+          <a:p>
+            <a:pPr marL="0" indent="0" algn="r">
+              <a:buNone/>
+            </a:pPr>
+            <a:r>
+              <a:rPr lang="en-US" sz="850" dirty="0">
+                <a:solidFill>
+                  <a:srgbClr val="6B7280"/>
+                </a:solidFill>
+                <a:latin typeface="Aptos" pitchFamily="34" charset="0"/>
+                <a:ea typeface="Aptos" pitchFamily="34" charset="-122"/>
+                <a:cs typeface="Aptos" pitchFamily="34" charset="-120"/>
+              </a:rPr>
+              <a:t>İleri Bilgisayarlı Görme ve Derin Öğrenme</a:t>
+            </a:r>
+            <a:endParaRPr lang="en-US" sz="850" dirty="0"/>
+          </a:p>
+        </p:txBody>
+      </p:sp>
+      <p:sp>
+        <p:nvSpPr>
+          <p:cNvPr id="8" name="Text 6"/>
+          <p:cNvSpPr/>
+          <p:nvPr/>
+        </p:nvSpPr>
+        <p:spPr>
+          <a:xfrm>
+            <a:off x="749808" y="1600200"/>
+            <a:ext cx="10378440" cy="3200400"/>
+          </a:xfrm>
+          <a:prstGeom prst="rect">
+            <a:avLst/>
+          </a:prstGeom>
+          <a:noFill/>
+          <a:ln/>
+        </p:spPr>
+        <p:txBody>
+          <a:bodyPr wrap="square" lIns="254" tIns="254" rIns="254" bIns="254" rtlCol="0" anchor="ctr">
+            <a:normAutofit/>
+          </a:bodyPr>
+          <a:lstStyle/>
+          <a:p>
+            <a:pPr marL="285750" indent="-285750">
+              <a:buFont typeface="Arial" panose="020B0604020202020204" pitchFamily="34" charset="0"/>
+              <a:buChar char="•"/>
+            </a:pPr>
+            <a:r>
+              <a:rPr lang="tr-TR" sz="1600" dirty="0"/>
+              <a:t>Swin Transformer literatürde ~%82.3 BA (Ayas) </a:t>
+            </a:r>
+          </a:p>
+          <a:p>
+            <a:pPr marL="285750" indent="-285750">
+              <a:buFont typeface="Arial" panose="020B0604020202020204" pitchFamily="34" charset="0"/>
+              <a:buChar char="•"/>
+            </a:pPr>
+            <a:r>
+              <a:rPr lang="tr-TR" sz="1600" dirty="0"/>
+              <a:t>Bu çalışma: </a:t>
+            </a:r>
+            <a:r>
+              <a:rPr lang="tr-TR" sz="1600" b="1" dirty="0"/>
+              <a:t>%82.4 BA</a:t>
+            </a:r>
+            <a:r>
+              <a:rPr lang="tr-TR" sz="1600" dirty="0"/>
+              <a:t> – %89~ Accuracy</a:t>
+            </a:r>
+          </a:p>
+          <a:p>
+            <a:pPr marL="285750" indent="-285750">
+              <a:buFont typeface="Arial" panose="020B0604020202020204" pitchFamily="34" charset="0"/>
+              <a:buChar char="•"/>
+            </a:pPr>
+            <a:r>
+              <a:rPr lang="tr-TR" sz="1600" dirty="0"/>
+              <a:t>CNN tabanlı çalışmalar: Bazı hibrit modeller %93+ Accuracy </a:t>
+            </a:r>
+          </a:p>
+          <a:p>
+            <a:pPr marL="285750" indent="-285750">
+              <a:buFont typeface="Arial" panose="020B0604020202020204" pitchFamily="34" charset="0"/>
+              <a:buChar char="•"/>
+            </a:pPr>
+            <a:r>
+              <a:rPr lang="tr-TR" sz="1600" dirty="0"/>
+              <a:t>Farklar Nedenleri</a:t>
+            </a:r>
+          </a:p>
+          <a:p>
+            <a:pPr marL="742950" lvl="1" indent="-285750">
+              <a:buFont typeface="Arial" panose="020B0604020202020204" pitchFamily="34" charset="0"/>
+              <a:buChar char="•"/>
+            </a:pPr>
+            <a:r>
+              <a:rPr lang="tr-TR" sz="1600" dirty="0"/>
+              <a:t>veri split </a:t>
+            </a:r>
+          </a:p>
+          <a:p>
+            <a:pPr marL="742950" lvl="1" indent="-285750">
+              <a:buFont typeface="Arial" panose="020B0604020202020204" pitchFamily="34" charset="0"/>
+              <a:buChar char="•"/>
+            </a:pPr>
+            <a:r>
+              <a:rPr lang="tr-TR" sz="1600" dirty="0"/>
+              <a:t>augmentation </a:t>
+            </a:r>
+          </a:p>
+          <a:p>
+            <a:pPr marL="742950" lvl="1" indent="-285750">
+              <a:buFont typeface="Arial" panose="020B0604020202020204" pitchFamily="34" charset="0"/>
+              <a:buChar char="•"/>
+            </a:pPr>
+            <a:r>
+              <a:rPr lang="tr-TR" sz="1600" dirty="0"/>
+              <a:t>model kapasitesi </a:t>
+            </a:r>
+          </a:p>
+          <a:p>
+            <a:pPr marL="742950" lvl="1" indent="-285750">
+              <a:buFont typeface="Arial" panose="020B0604020202020204" pitchFamily="34" charset="0"/>
+              <a:buChar char="•"/>
+            </a:pPr>
+            <a:r>
+              <a:rPr lang="tr-TR" sz="1600" dirty="0"/>
+              <a:t>training protocol</a:t>
+            </a:r>
+          </a:p>
+        </p:txBody>
+      </p:sp>
+      <p:sp>
+        <p:nvSpPr>
+          <p:cNvPr id="9" name="Shape 7"/>
+          <p:cNvSpPr/>
+          <p:nvPr/>
+        </p:nvSpPr>
+        <p:spPr>
+          <a:xfrm>
+            <a:off x="749808" y="5074920"/>
+            <a:ext cx="10378440" cy="713232"/>
+          </a:xfrm>
+          <a:prstGeom prst="rect">
+            <a:avLst/>
+          </a:prstGeom>
+          <a:solidFill>
+            <a:srgbClr val="EEF2F7"/>
+          </a:solidFill>
+          <a:ln w="12700">
+            <a:solidFill>
+              <a:srgbClr val="CBD5E1">
+                <a:alpha val="80000"/>
+              </a:srgbClr>
+            </a:solidFill>
+            <a:prstDash val="solid"/>
+          </a:ln>
+        </p:spPr>
+        <p:txBody>
+          <a:bodyPr/>
+          <a:lstStyle/>
+          <a:p>
+            <a:endParaRPr lang="tr-TR"/>
+          </a:p>
+        </p:txBody>
+      </p:sp>
+      <p:sp>
+        <p:nvSpPr>
+          <p:cNvPr id="10" name="Text 8"/>
+          <p:cNvSpPr/>
+          <p:nvPr/>
+        </p:nvSpPr>
+        <p:spPr>
+          <a:xfrm>
+            <a:off x="987552" y="5248656"/>
+            <a:ext cx="9921240" cy="347472"/>
+          </a:xfrm>
+          <a:prstGeom prst="rect">
+            <a:avLst/>
+          </a:prstGeom>
+          <a:noFill/>
+          <a:ln/>
+        </p:spPr>
+        <p:txBody>
+          <a:bodyPr wrap="square" lIns="127" tIns="127" rIns="127" bIns="127" rtlCol="0" anchor="ctr">
+            <a:normAutofit/>
+          </a:bodyPr>
+          <a:lstStyle/>
+          <a:p>
+            <a:pPr marL="0" indent="0">
+              <a:buNone/>
+            </a:pPr>
+            <a:r>
+              <a:rPr lang="en-US" sz="1200" i="1" dirty="0">
+                <a:solidFill>
+                  <a:srgbClr val="1E2A5A"/>
+                </a:solidFill>
+                <a:latin typeface="Aptos" pitchFamily="34" charset="0"/>
+                <a:ea typeface="Aptos" pitchFamily="34" charset="-122"/>
+                <a:cs typeface="Aptos" pitchFamily="34" charset="-120"/>
+              </a:rPr>
+              <a:t>Makaledeki literatür ve tartışma bölümlerinizden seçilmiş kısa bir özet yeterlidir.</a:t>
+            </a:r>
+            <a:endParaRPr lang="en-US" sz="1200" dirty="0"/>
+          </a:p>
+        </p:txBody>
+      </p:sp>
+    </p:spTree>
+  </p:cSld>
+  <p:clrMapOvr>
+    <a:masterClrMapping/>
+  </p:clrMapOvr>
+</p:sld>
+</file>
+
+<file path=ppt/slides/slide11.xml><?xml version="1.0" encoding="utf-8"?>
+<p:sld xmlns:a="http://schemas.openxmlformats.org/drawingml/2006/main" xmlns:r="http://schemas.openxmlformats.org/officeDocument/2006/relationships" xmlns:p="http://schemas.openxmlformats.org/presentationml/2006/main">
+  <p:cSld name="Slide 9">
+    <p:bg>
+      <p:bgPr>
+        <a:solidFill>
+          <a:srgbClr val="F8FAFC"/>
+        </a:solidFill>
+        <a:effectLst/>
+      </p:bgPr>
+    </p:bg>
+    <p:spTree>
+      <p:nvGrpSpPr>
+        <p:cNvPr id="1" name=""/>
+        <p:cNvGrpSpPr/>
+        <p:nvPr/>
+      </p:nvGrpSpPr>
+      <p:grpSpPr>
+        <a:xfrm>
+          <a:off x="0" y="0"/>
+          <a:ext cx="0" cy="0"/>
+          <a:chOff x="0" y="0"/>
+          <a:chExt cx="0" cy="0"/>
+        </a:xfrm>
+      </p:grpSpPr>
+      <p:sp>
+        <p:nvSpPr>
+          <p:cNvPr id="2" name="Shape 0"/>
+          <p:cNvSpPr/>
+          <p:nvPr/>
+        </p:nvSpPr>
+        <p:spPr>
+          <a:xfrm>
+            <a:off x="0" y="0"/>
+            <a:ext cx="12191695" cy="146304"/>
+          </a:xfrm>
+          <a:prstGeom prst="rect">
+            <a:avLst/>
+          </a:prstGeom>
+          <a:solidFill>
+            <a:srgbClr val="1E2A5A"/>
+          </a:solidFill>
+          <a:ln w="12700">
+            <a:solidFill>
+              <a:srgbClr val="1E2A5A"/>
+            </a:solidFill>
+            <a:prstDash val="solid"/>
+          </a:ln>
+        </p:spPr>
+        <p:txBody>
+          <a:bodyPr/>
+          <a:lstStyle/>
+          <a:p>
+            <a:endParaRPr lang="tr-TR"/>
+          </a:p>
+        </p:txBody>
+      </p:sp>
+      <p:sp>
+        <p:nvSpPr>
+          <p:cNvPr id="3" name="Text 1"/>
+          <p:cNvSpPr/>
+          <p:nvPr/>
+        </p:nvSpPr>
+        <p:spPr>
+          <a:xfrm>
+            <a:off x="594360" y="438912"/>
+            <a:ext cx="8138160" cy="384048"/>
+          </a:xfrm>
+          <a:prstGeom prst="rect">
+            <a:avLst/>
+          </a:prstGeom>
+          <a:noFill/>
+          <a:ln/>
+        </p:spPr>
+        <p:txBody>
+          <a:bodyPr wrap="square" lIns="0" tIns="0" rIns="0" bIns="0" rtlCol="0" anchor="ctr"/>
+          <a:lstStyle/>
+          <a:p>
+            <a:pPr marL="0" indent="0">
+              <a:buNone/>
+            </a:pPr>
+            <a:r>
+              <a:rPr lang="tr-TR" sz="2400" b="1" dirty="0">
+                <a:solidFill>
+                  <a:srgbClr val="1E2A5A"/>
+                </a:solidFill>
+                <a:latin typeface="Aptos Display" pitchFamily="34" charset="0"/>
+                <a:ea typeface="Aptos Display" pitchFamily="34" charset="-122"/>
+                <a:cs typeface="Aptos Display" pitchFamily="34" charset="-120"/>
+              </a:rPr>
+              <a:t>10</a:t>
+            </a:r>
+            <a:r>
+              <a:rPr lang="en-US" sz="2400" b="1" dirty="0">
+                <a:solidFill>
+                  <a:srgbClr val="1E2A5A"/>
+                </a:solidFill>
+                <a:latin typeface="Aptos Display" pitchFamily="34" charset="0"/>
+                <a:ea typeface="Aptos Display" pitchFamily="34" charset="-122"/>
+                <a:cs typeface="Aptos Display" pitchFamily="34" charset="-120"/>
+              </a:rPr>
+              <a:t>. Tartışma ve Sınırlılıklar</a:t>
+            </a:r>
+            <a:endParaRPr lang="en-US" sz="2400" dirty="0"/>
+          </a:p>
+        </p:txBody>
+      </p:sp>
+      <p:sp>
+        <p:nvSpPr>
+          <p:cNvPr id="4" name="Text 2"/>
+          <p:cNvSpPr/>
+          <p:nvPr/>
+        </p:nvSpPr>
+        <p:spPr>
+          <a:xfrm>
+            <a:off x="612648" y="896112"/>
+            <a:ext cx="9966960" cy="256032"/>
+          </a:xfrm>
+          <a:prstGeom prst="rect">
+            <a:avLst/>
+          </a:prstGeom>
+          <a:noFill/>
+          <a:ln/>
+        </p:spPr>
+        <p:txBody>
+          <a:bodyPr wrap="square" lIns="0" tIns="0" rIns="0" bIns="0" rtlCol="0" anchor="ctr"/>
+          <a:lstStyle/>
+          <a:p>
+            <a:pPr marL="0" indent="0">
+              <a:buNone/>
+            </a:pPr>
+            <a:r>
+              <a:rPr lang="en-US" sz="1050" i="1" dirty="0">
+                <a:solidFill>
+                  <a:srgbClr val="6B7280"/>
+                </a:solidFill>
+                <a:latin typeface="Aptos" pitchFamily="34" charset="0"/>
+                <a:ea typeface="Aptos" pitchFamily="34" charset="-122"/>
+                <a:cs typeface="Aptos" pitchFamily="34" charset="-120"/>
+              </a:rPr>
+              <a:t>Çalışmanın güçlü ve sınırlı yönlerini açıkça ifade edin.</a:t>
+            </a:r>
+            <a:endParaRPr lang="en-US" sz="1050" dirty="0"/>
+          </a:p>
+        </p:txBody>
+      </p:sp>
+      <p:sp>
+        <p:nvSpPr>
+          <p:cNvPr id="5" name="Shape 3"/>
+          <p:cNvSpPr/>
+          <p:nvPr/>
+        </p:nvSpPr>
+        <p:spPr>
+          <a:xfrm>
+            <a:off x="594360" y="1261872"/>
+            <a:ext cx="10972800" cy="0"/>
+          </a:xfrm>
+          <a:prstGeom prst="line">
+            <a:avLst/>
+          </a:prstGeom>
+          <a:noFill/>
+          <a:ln w="9525">
+            <a:solidFill>
+              <a:srgbClr val="CBD5E1"/>
+            </a:solidFill>
+            <a:prstDash val="solid"/>
+          </a:ln>
+        </p:spPr>
+        <p:txBody>
+          <a:bodyPr/>
+          <a:lstStyle/>
+          <a:p>
+            <a:endParaRPr lang="tr-TR"/>
+          </a:p>
+        </p:txBody>
+      </p:sp>
+      <p:sp>
+        <p:nvSpPr>
+          <p:cNvPr id="6" name="Text 4"/>
+          <p:cNvSpPr/>
+          <p:nvPr/>
+        </p:nvSpPr>
+        <p:spPr>
+          <a:xfrm>
+            <a:off x="594360" y="6510528"/>
+            <a:ext cx="5029200" cy="201168"/>
+          </a:xfrm>
+          <a:prstGeom prst="rect">
+            <a:avLst/>
+          </a:prstGeom>
+          <a:noFill/>
+          <a:ln/>
+        </p:spPr>
+        <p:txBody>
+          <a:bodyPr wrap="square" lIns="0" tIns="0" rIns="0" bIns="0" rtlCol="0" anchor="ctr"/>
+          <a:lstStyle/>
+          <a:p>
+            <a:r>
+              <a:rPr lang="en-US" sz="850" dirty="0">
+                <a:solidFill>
+                  <a:srgbClr val="6B7280"/>
+                </a:solidFill>
+                <a:latin typeface="Aptos" pitchFamily="34" charset="0"/>
+                <a:ea typeface="Aptos" pitchFamily="34" charset="-122"/>
+                <a:cs typeface="Aptos" pitchFamily="34" charset="-120"/>
+              </a:rPr>
+              <a:t>Final Makale/Bildiri Sunumu  •  </a:t>
+            </a:r>
+            <a:r>
+              <a:rPr lang="tr-TR" sz="850" dirty="0">
+                <a:solidFill>
+                  <a:srgbClr val="6B7280"/>
+                </a:solidFill>
+                <a:latin typeface="Aptos" pitchFamily="34" charset="0"/>
+                <a:ea typeface="Aptos" pitchFamily="34" charset="-122"/>
+                <a:cs typeface="Aptos" pitchFamily="34" charset="-120"/>
+              </a:rPr>
+              <a:t>11</a:t>
+            </a:r>
+            <a:r>
+              <a:rPr lang="en-US" sz="850" dirty="0">
+                <a:solidFill>
+                  <a:srgbClr val="6B7280"/>
+                </a:solidFill>
+                <a:latin typeface="Aptos" pitchFamily="34" charset="0"/>
+                <a:ea typeface="Aptos" pitchFamily="34" charset="-122"/>
+                <a:cs typeface="Aptos" pitchFamily="34" charset="-120"/>
+              </a:rPr>
+              <a:t> /1</a:t>
+            </a:r>
+            <a:r>
+              <a:rPr lang="tr-TR" sz="850" dirty="0">
+                <a:solidFill>
+                  <a:srgbClr val="6B7280"/>
+                </a:solidFill>
+                <a:latin typeface="Aptos" pitchFamily="34" charset="0"/>
+                <a:ea typeface="Aptos" pitchFamily="34" charset="-122"/>
+                <a:cs typeface="Aptos" pitchFamily="34" charset="-120"/>
+              </a:rPr>
+              <a:t>2</a:t>
+            </a:r>
+            <a:endParaRPr lang="en-US" sz="850" dirty="0"/>
+          </a:p>
+        </p:txBody>
+      </p:sp>
+      <p:sp>
+        <p:nvSpPr>
+          <p:cNvPr id="7" name="Text 5"/>
+          <p:cNvSpPr/>
+          <p:nvPr/>
+        </p:nvSpPr>
+        <p:spPr>
+          <a:xfrm>
+            <a:off x="6995160" y="6510528"/>
+            <a:ext cx="4572000" cy="201168"/>
+          </a:xfrm>
+          <a:prstGeom prst="rect">
+            <a:avLst/>
+          </a:prstGeom>
+          <a:noFill/>
+          <a:ln/>
+        </p:spPr>
+        <p:txBody>
+          <a:bodyPr wrap="square" lIns="0" tIns="0" rIns="0" bIns="0" rtlCol="0" anchor="ctr"/>
+          <a:lstStyle/>
+          <a:p>
+            <a:pPr marL="0" indent="0" algn="r">
+              <a:buNone/>
+            </a:pPr>
+            <a:r>
+              <a:rPr lang="en-US" sz="850" dirty="0">
+                <a:solidFill>
+                  <a:srgbClr val="6B7280"/>
+                </a:solidFill>
+                <a:latin typeface="Aptos" pitchFamily="34" charset="0"/>
+                <a:ea typeface="Aptos" pitchFamily="34" charset="-122"/>
+                <a:cs typeface="Aptos" pitchFamily="34" charset="-120"/>
+              </a:rPr>
+              <a:t>İleri Bilgisayarlı Görme ve Derin Öğrenme</a:t>
+            </a:r>
+            <a:endParaRPr lang="en-US" sz="850" dirty="0"/>
+          </a:p>
+        </p:txBody>
+      </p:sp>
+      <p:sp>
+        <p:nvSpPr>
+          <p:cNvPr id="8" name="Text 6"/>
+          <p:cNvSpPr/>
+          <p:nvPr/>
+        </p:nvSpPr>
+        <p:spPr>
+          <a:xfrm>
+            <a:off x="749808" y="1600200"/>
+            <a:ext cx="10378440" cy="3200400"/>
+          </a:xfrm>
+          <a:prstGeom prst="rect">
+            <a:avLst/>
+          </a:prstGeom>
+          <a:noFill/>
+          <a:ln/>
+        </p:spPr>
+        <p:txBody>
+          <a:bodyPr wrap="square" lIns="254" tIns="254" rIns="254" bIns="254" rtlCol="0" anchor="ctr">
+            <a:normAutofit/>
+          </a:bodyPr>
+          <a:lstStyle/>
+          <a:p>
+            <a:pPr marL="285750" indent="-285750">
+              <a:buFont typeface="Arial" panose="020B0604020202020204" pitchFamily="34" charset="0"/>
+              <a:buChar char="•"/>
+            </a:pPr>
+            <a:r>
+              <a:rPr lang="tr-TR" sz="1600" b="1" dirty="0"/>
+              <a:t>Güçlü yönler:</a:t>
+            </a:r>
+            <a:endParaRPr lang="tr-TR" sz="1600" dirty="0"/>
+          </a:p>
+          <a:p>
+            <a:pPr marL="742950" lvl="1" indent="-285750">
+              <a:buFont typeface="Arial" panose="020B0604020202020204" pitchFamily="34" charset="0"/>
+              <a:buChar char="•"/>
+            </a:pPr>
+            <a:r>
+              <a:rPr lang="tr-TR" sz="1600" dirty="0"/>
+              <a:t>Tüm modeller aynı koşulda karşılaştırıldı </a:t>
+            </a:r>
+          </a:p>
+          <a:p>
+            <a:pPr marL="742950" lvl="1" indent="-285750">
+              <a:buFont typeface="Arial" panose="020B0604020202020204" pitchFamily="34" charset="0"/>
+              <a:buChar char="•"/>
+            </a:pPr>
+            <a:r>
+              <a:rPr lang="tr-TR" sz="1600" dirty="0"/>
+              <a:t>Adil benchmarking yapıldı </a:t>
+            </a:r>
+          </a:p>
+          <a:p>
+            <a:pPr marL="285750" indent="-285750">
+              <a:buFont typeface="Arial" panose="020B0604020202020204" pitchFamily="34" charset="0"/>
+              <a:buChar char="•"/>
+            </a:pPr>
+            <a:endParaRPr lang="tr-TR" sz="1600" b="1" dirty="0"/>
+          </a:p>
+          <a:p>
+            <a:pPr marL="285750" indent="-285750">
+              <a:buFont typeface="Arial" panose="020B0604020202020204" pitchFamily="34" charset="0"/>
+              <a:buChar char="•"/>
+            </a:pPr>
+            <a:r>
+              <a:rPr lang="tr-TR" sz="1600" b="1" dirty="0"/>
+              <a:t>Sınırlılıklar:</a:t>
+            </a:r>
+            <a:endParaRPr lang="tr-TR" sz="1600" dirty="0"/>
+          </a:p>
+          <a:p>
+            <a:pPr marL="742950" lvl="1" indent="-285750">
+              <a:buFont typeface="Arial" panose="020B0604020202020204" pitchFamily="34" charset="0"/>
+              <a:buChar char="•"/>
+            </a:pPr>
+            <a:r>
+              <a:rPr lang="tr-TR" sz="1600" dirty="0"/>
+              <a:t>Tek seed </a:t>
+            </a:r>
+          </a:p>
+          <a:p>
+            <a:pPr marL="742950" lvl="1" indent="-285750">
+              <a:buFont typeface="Arial" panose="020B0604020202020204" pitchFamily="34" charset="0"/>
+              <a:buChar char="•"/>
+            </a:pPr>
+            <a:r>
+              <a:rPr lang="tr-TR" sz="1600" dirty="0"/>
+              <a:t>50 epoch limit </a:t>
+            </a:r>
+          </a:p>
+          <a:p>
+            <a:pPr marL="742950" lvl="1" indent="-285750">
+              <a:buFont typeface="Arial" panose="020B0604020202020204" pitchFamily="34" charset="0"/>
+              <a:buChar char="•"/>
+            </a:pPr>
+            <a:r>
+              <a:rPr lang="tr-TR" sz="1600" dirty="0"/>
+              <a:t>Class imbalance (NV baskın) </a:t>
+            </a:r>
+          </a:p>
+          <a:p>
+            <a:pPr marL="742950" lvl="1" indent="-285750">
+              <a:buFont typeface="Arial" panose="020B0604020202020204" pitchFamily="34" charset="0"/>
+              <a:buChar char="•"/>
+            </a:pPr>
+            <a:r>
+              <a:rPr lang="tr-TR" sz="1600" dirty="0"/>
+              <a:t>Sadece ImageNet pretrained modeller</a:t>
+            </a:r>
+          </a:p>
+        </p:txBody>
+      </p:sp>
+      <p:sp>
+        <p:nvSpPr>
+          <p:cNvPr id="9" name="Shape 7"/>
+          <p:cNvSpPr/>
+          <p:nvPr/>
+        </p:nvSpPr>
+        <p:spPr>
+          <a:xfrm>
+            <a:off x="749808" y="5074920"/>
+            <a:ext cx="10378440" cy="713232"/>
+          </a:xfrm>
+          <a:prstGeom prst="rect">
+            <a:avLst/>
+          </a:prstGeom>
+          <a:solidFill>
+            <a:srgbClr val="EEF2F7"/>
+          </a:solidFill>
+          <a:ln w="12700">
+            <a:solidFill>
+              <a:srgbClr val="CBD5E1">
+                <a:alpha val="80000"/>
+              </a:srgbClr>
+            </a:solidFill>
+            <a:prstDash val="solid"/>
+          </a:ln>
+        </p:spPr>
+        <p:txBody>
+          <a:bodyPr/>
+          <a:lstStyle/>
+          <a:p>
+            <a:endParaRPr lang="tr-TR"/>
+          </a:p>
+        </p:txBody>
+      </p:sp>
+      <p:sp>
+        <p:nvSpPr>
+          <p:cNvPr id="10" name="Text 8"/>
+          <p:cNvSpPr/>
+          <p:nvPr/>
+        </p:nvSpPr>
+        <p:spPr>
+          <a:xfrm>
+            <a:off x="987552" y="5248656"/>
+            <a:ext cx="9921240" cy="347472"/>
+          </a:xfrm>
+          <a:prstGeom prst="rect">
+            <a:avLst/>
+          </a:prstGeom>
+          <a:noFill/>
+          <a:ln/>
+        </p:spPr>
+        <p:txBody>
+          <a:bodyPr wrap="square" lIns="127" tIns="127" rIns="127" bIns="127" rtlCol="0" anchor="ctr">
+            <a:normAutofit/>
+          </a:bodyPr>
+          <a:lstStyle/>
+          <a:p>
+            <a:pPr marL="0" indent="0">
+              <a:buNone/>
+            </a:pPr>
+            <a:r>
+              <a:rPr lang="en-US" sz="1200" i="1" dirty="0">
+                <a:solidFill>
+                  <a:srgbClr val="1E2A5A"/>
+                </a:solidFill>
+                <a:latin typeface="Aptos" pitchFamily="34" charset="0"/>
+                <a:ea typeface="Aptos" pitchFamily="34" charset="-122"/>
+                <a:cs typeface="Aptos" pitchFamily="34" charset="-120"/>
+              </a:rPr>
+              <a:t>Sınırlılık yazmak çalışmayı zayıflatmaz; aksine akademik olgunluk gösterir.</a:t>
+            </a:r>
+            <a:endParaRPr lang="en-US" sz="1200" dirty="0"/>
+          </a:p>
+        </p:txBody>
+      </p:sp>
+    </p:spTree>
+  </p:cSld>
+  <p:clrMapOvr>
+    <a:masterClrMapping/>
+  </p:clrMapOvr>
+</p:sld>
+</file>
+
+<file path=ppt/slides/slide12.xml><?xml version="1.0" encoding="utf-8"?>
 <p:sld xmlns:a="http://schemas.openxmlformats.org/drawingml/2006/main" xmlns:r="http://schemas.openxmlformats.org/officeDocument/2006/relationships" xmlns:p="http://schemas.openxmlformats.org/presentationml/2006/main">
   <p:cSld name="Slide 10">
     <p:bg>
@@ -1950,7 +3135,7 @@
               <a:buNone/>
             </a:pPr>
             <a:r>
-              <a:rPr lang="en-US" sz="2400" b="1" dirty="0">
+              <a:rPr lang="tr-TR" sz="2400" b="1" dirty="0">
                 <a:solidFill>
                   <a:srgbClr val="1E2A5A"/>
                 </a:solidFill>
@@ -1958,7 +3143,18 @@
                 <a:ea typeface="Aptos Display" pitchFamily="34" charset="-122"/>
                 <a:cs typeface="Aptos Display" pitchFamily="34" charset="-120"/>
               </a:rPr>
-              <a:t>9. Sonuç ve Kaynaklar</a:t>
+              <a:t>11</a:t>
+            </a:r>
+            <a:r>
+              <a:rPr lang="en-US" sz="2400" b="1" dirty="0">
+                <a:solidFill>
+                  <a:srgbClr val="1E2A5A"/>
+                </a:solidFill>
+                <a:latin typeface="Aptos Display" pitchFamily="34" charset="0"/>
+                <a:ea typeface="Aptos Display" pitchFamily="34" charset="-122"/>
+                <a:cs typeface="Aptos Display" pitchFamily="34" charset="-120"/>
+              </a:rPr>
+              <a:t>. Sonuç ve Kaynaklar</a:t>
             </a:r>
             <a:endParaRPr lang="en-US" sz="2400" dirty="0"/>
           </a:p>
@@ -2066,38 +3262,10 @@
                 <a:ea typeface="Aptos" pitchFamily="34" charset="-122"/>
                 <a:cs typeface="Aptos" pitchFamily="34" charset="-120"/>
               </a:rPr>
-              <a:t>Final Makale/Bildiri Sunumu  •  10/10</a:t>
-            </a:r>
-            <a:endParaRPr lang="en-US" sz="850" dirty="0"/>
-          </a:p>
-        </p:txBody>
-      </p:sp>
-      <p:sp>
-        <p:nvSpPr>
-          <p:cNvPr id="7" name="Text 5"/>
-          <p:cNvSpPr/>
-          <p:nvPr/>
-        </p:nvSpPr>
-        <p:spPr>
-          <a:xfrm>
-            <a:off x="6995160" y="6510528"/>
-            <a:ext cx="4572000" cy="201168"/>
-          </a:xfrm>
-          <a:prstGeom prst="rect">
-            <a:avLst/>
-          </a:prstGeom>
-          <a:noFill/>
-          <a:ln/>
-        </p:spPr>
-        <p:txBody>
-          <a:bodyPr wrap="square" lIns="0" tIns="0" rIns="0" bIns="0" rtlCol="0" anchor="ctr"/>
-          <a:lstStyle/>
-          <a:p>
-            <a:pPr marL="0" indent="0" algn="r">
-              <a:buNone/>
-            </a:pPr>
-            <a:r>
-              <a:rPr lang="en-US" sz="850" dirty="0">
+              <a:t>Final Makale/Bildiri Sunumu  •  1</a:t>
+            </a:r>
+            <a:r>
+              <a:rPr lang="tr-TR" sz="850" dirty="0">
                 <a:solidFill>
                   <a:srgbClr val="6B7280"/>
                 </a:solidFill>
@@ -2105,6 +3273,67 @@
                 <a:ea typeface="Aptos" pitchFamily="34" charset="-122"/>
                 <a:cs typeface="Aptos" pitchFamily="34" charset="-120"/>
               </a:rPr>
+              <a:t>2</a:t>
+            </a:r>
+            <a:r>
+              <a:rPr lang="en-US" sz="850" dirty="0">
+                <a:solidFill>
+                  <a:srgbClr val="6B7280"/>
+                </a:solidFill>
+                <a:latin typeface="Aptos" pitchFamily="34" charset="0"/>
+                <a:ea typeface="Aptos" pitchFamily="34" charset="-122"/>
+                <a:cs typeface="Aptos" pitchFamily="34" charset="-120"/>
+              </a:rPr>
+              <a:t>/1</a:t>
+            </a:r>
+            <a:r>
+              <a:rPr lang="tr-TR" sz="850" dirty="0">
+                <a:solidFill>
+                  <a:srgbClr val="6B7280"/>
+                </a:solidFill>
+                <a:latin typeface="Aptos" pitchFamily="34" charset="0"/>
+                <a:ea typeface="Aptos" pitchFamily="34" charset="-122"/>
+                <a:cs typeface="Aptos" pitchFamily="34" charset="-120"/>
+              </a:rPr>
+              <a:t>2</a:t>
+            </a:r>
+            <a:endParaRPr lang="en-US" sz="850" dirty="0"/>
+          </a:p>
+        </p:txBody>
+      </p:sp>
+      <p:sp>
+        <p:nvSpPr>
+          <p:cNvPr id="7" name="Text 5"/>
+          <p:cNvSpPr/>
+          <p:nvPr/>
+        </p:nvSpPr>
+        <p:spPr>
+          <a:xfrm>
+            <a:off x="6995160" y="6510528"/>
+            <a:ext cx="4572000" cy="201168"/>
+          </a:xfrm>
+          <a:prstGeom prst="rect">
+            <a:avLst/>
+          </a:prstGeom>
+          <a:noFill/>
+          <a:ln/>
+        </p:spPr>
+        <p:txBody>
+          <a:bodyPr wrap="square" lIns="0" tIns="0" rIns="0" bIns="0" rtlCol="0" anchor="ctr"/>
+          <a:lstStyle/>
+          <a:p>
+            <a:pPr marL="0" indent="0" algn="r">
+              <a:buNone/>
+            </a:pPr>
+            <a:r>
+              <a:rPr lang="en-US" sz="850" dirty="0">
+                <a:solidFill>
+                  <a:srgbClr val="6B7280"/>
+                </a:solidFill>
+                <a:latin typeface="Aptos" pitchFamily="34" charset="0"/>
+                <a:ea typeface="Aptos" pitchFamily="34" charset="-122"/>
+                <a:cs typeface="Aptos" pitchFamily="34" charset="-120"/>
+              </a:rPr>
               <a:t>İleri Bilgisayarlı Görme ve Derin Öğrenme</a:t>
             </a:r>
             <a:endParaRPr lang="en-US" sz="850" dirty="0"/>
@@ -2134,58 +3363,43 @@
           </a:bodyPr>
           <a:lstStyle/>
           <a:p>
-            <a:r>
-              <a:rPr lang="en-US" sz="1550" dirty="0">
-                <a:solidFill>
-                  <a:srgbClr val="111827"/>
-                </a:solidFill>
-                <a:latin typeface="Aptos" pitchFamily="34" charset="0"/>
-                <a:ea typeface="Aptos" pitchFamily="34" charset="-122"/>
-                <a:cs typeface="Aptos" pitchFamily="34" charset="-120"/>
-              </a:rPr>
-              <a:t>Çalışmanın en önemli sonucu veya çıkarımı.</a:t>
-            </a:r>
-            <a:endParaRPr lang="en-US" sz="1550" dirty="0"/>
-          </a:p>
-          <a:p>
-            <a:r>
-              <a:rPr lang="en-US" sz="1550" dirty="0">
-                <a:solidFill>
-                  <a:srgbClr val="111827"/>
-                </a:solidFill>
-                <a:latin typeface="Aptos" pitchFamily="34" charset="0"/>
-                <a:ea typeface="Aptos" pitchFamily="34" charset="-122"/>
-                <a:cs typeface="Aptos" pitchFamily="34" charset="-120"/>
-              </a:rPr>
-              <a:t>Gelecekte yapılabilecek bir geliştirme önerisi.</a:t>
-            </a:r>
-            <a:endParaRPr lang="en-US" sz="1550" dirty="0"/>
-          </a:p>
-          <a:p>
-            <a:r>
-              <a:rPr lang="en-US" sz="1550" dirty="0">
-                <a:solidFill>
-                  <a:srgbClr val="111827"/>
-                </a:solidFill>
-                <a:latin typeface="Aptos" pitchFamily="34" charset="0"/>
-                <a:ea typeface="Aptos" pitchFamily="34" charset="-122"/>
-                <a:cs typeface="Aptos" pitchFamily="34" charset="-120"/>
-              </a:rPr>
-              <a:t>Kullanılan veri kümesi, temel makaleler, model/kütüphane ve dokümantasyon kaynakları.</a:t>
-            </a:r>
-            <a:endParaRPr lang="en-US" sz="1550" dirty="0"/>
-          </a:p>
-          <a:p>
-            <a:r>
-              <a:rPr lang="en-US" sz="1550" dirty="0">
-                <a:solidFill>
-                  <a:srgbClr val="111827"/>
-                </a:solidFill>
-                <a:latin typeface="Aptos" pitchFamily="34" charset="0"/>
-                <a:ea typeface="Aptos" pitchFamily="34" charset="-122"/>
-                <a:cs typeface="Aptos" pitchFamily="34" charset="-120"/>
-              </a:rPr>
-              <a:t>Kaynak sayısı fazlaysa, bu slayt ikiye bölünebilir veya kaynaklar ek slayta taşınabilir.</a:t>
+            <a:pPr marL="285750" indent="-285750">
+              <a:buFont typeface="Arial" panose="020B0604020202020204" pitchFamily="34" charset="0"/>
+              <a:buChar char="•"/>
+            </a:pPr>
+            <a:r>
+              <a:rPr lang="tr-TR" sz="1600" dirty="0"/>
+              <a:t>ISIC2019 dataset</a:t>
+            </a:r>
+          </a:p>
+          <a:p>
+            <a:pPr marL="285750" indent="-285750">
+              <a:buFont typeface="Arial" panose="020B0604020202020204" pitchFamily="34" charset="0"/>
+              <a:buChar char="•"/>
+            </a:pPr>
+            <a:r>
+              <a:rPr lang="tr-TR" sz="1600" dirty="0"/>
+              <a:t>Vision Transformer literature (ViT, Swin, DeiT vs.)</a:t>
+            </a:r>
+          </a:p>
+          <a:p>
+            <a:pPr marL="285750" indent="-285750">
+              <a:buFont typeface="Arial" panose="020B0604020202020204" pitchFamily="34" charset="0"/>
+              <a:buChar char="•"/>
+            </a:pPr>
+            <a:r>
+              <a:rPr lang="tr-TR" sz="1600" dirty="0"/>
+              <a:t>PyTorch + timm library</a:t>
+            </a:r>
+          </a:p>
+          <a:p>
+            <a:pPr marL="285750" indent="-285750">
+              <a:buFont typeface="Arial" panose="020B0604020202020204" pitchFamily="34" charset="0"/>
+              <a:buChar char="•"/>
+            </a:pPr>
+            <a:r>
+              <a:rPr lang="tr-TR" sz="1600" dirty="0"/>
+              <a:t>IEEE / arXiv papers</a:t>
             </a:r>
             <a:endParaRPr lang="en-US" sz="1550" dirty="0"/>
           </a:p>
@@ -2460,9 +3674,6 @@
           <a:bodyPr wrap="square" lIns="0" tIns="0" rIns="0" bIns="0" rtlCol="0" anchor="ctr"/>
           <a:lstStyle/>
           <a:p>
-            <a:pPr marL="0" indent="0">
-              <a:buNone/>
-            </a:pPr>
             <a:r>
               <a:rPr lang="en-US" sz="850" dirty="0">
                 <a:solidFill>
@@ -2472,7 +3683,18 @@
                 <a:ea typeface="Aptos" pitchFamily="34" charset="-122"/>
                 <a:cs typeface="Aptos" pitchFamily="34" charset="-120"/>
               </a:rPr>
-              <a:t>Final Makale/Bildiri Sunumu  •  2/10</a:t>
+              <a:t>Final Makale/Bildiri Sunumu  •  2 /1</a:t>
+            </a:r>
+            <a:r>
+              <a:rPr lang="tr-TR" sz="850" dirty="0">
+                <a:solidFill>
+                  <a:srgbClr val="6B7280"/>
+                </a:solidFill>
+                <a:latin typeface="Aptos" pitchFamily="34" charset="0"/>
+                <a:ea typeface="Aptos" pitchFamily="34" charset="-122"/>
+                <a:cs typeface="Aptos" pitchFamily="34" charset="-120"/>
+              </a:rPr>
+              <a:t>2</a:t>
             </a:r>
             <a:endParaRPr lang="en-US" sz="850" dirty="0"/>
           </a:p>
@@ -2851,9 +4073,6 @@
           <a:bodyPr wrap="square" lIns="0" tIns="0" rIns="0" bIns="0" rtlCol="0" anchor="ctr"/>
           <a:lstStyle/>
           <a:p>
-            <a:pPr marL="0" indent="0">
-              <a:buNone/>
-            </a:pPr>
             <a:r>
               <a:rPr lang="en-US" sz="850" dirty="0">
                 <a:solidFill>
@@ -2863,7 +4082,18 @@
                 <a:ea typeface="Aptos" pitchFamily="34" charset="-122"/>
                 <a:cs typeface="Aptos" pitchFamily="34" charset="-120"/>
               </a:rPr>
-              <a:t>Final Makale/Bildiri Sunumu  •  3/10</a:t>
+              <a:t>Final Makale/Bildiri Sunumu  •  3 /1</a:t>
+            </a:r>
+            <a:r>
+              <a:rPr lang="tr-TR" sz="850" dirty="0">
+                <a:solidFill>
+                  <a:srgbClr val="6B7280"/>
+                </a:solidFill>
+                <a:latin typeface="Aptos" pitchFamily="34" charset="0"/>
+                <a:ea typeface="Aptos" pitchFamily="34" charset="-122"/>
+                <a:cs typeface="Aptos" pitchFamily="34" charset="-120"/>
+              </a:rPr>
+              <a:t>2</a:t>
             </a:r>
             <a:endParaRPr lang="en-US" sz="850" dirty="0"/>
           </a:p>
@@ -3300,9 +4530,6 @@
           <a:bodyPr wrap="square" lIns="0" tIns="0" rIns="0" bIns="0" rtlCol="0" anchor="ctr"/>
           <a:lstStyle/>
           <a:p>
-            <a:pPr marL="0" indent="0">
-              <a:buNone/>
-            </a:pPr>
             <a:r>
               <a:rPr lang="en-US" sz="850" dirty="0">
                 <a:solidFill>
@@ -3312,7 +4539,18 @@
                 <a:ea typeface="Aptos" pitchFamily="34" charset="-122"/>
                 <a:cs typeface="Aptos" pitchFamily="34" charset="-120"/>
               </a:rPr>
-              <a:t>Final Makale/Bildiri Sunumu  •  4/10</a:t>
+              <a:t>Final Makale/Bildiri Sunumu  •  4 /1</a:t>
+            </a:r>
+            <a:r>
+              <a:rPr lang="tr-TR" sz="850" dirty="0">
+                <a:solidFill>
+                  <a:srgbClr val="6B7280"/>
+                </a:solidFill>
+                <a:latin typeface="Aptos" pitchFamily="34" charset="0"/>
+                <a:ea typeface="Aptos" pitchFamily="34" charset="-122"/>
+                <a:cs typeface="Aptos" pitchFamily="34" charset="-120"/>
+              </a:rPr>
+              <a:t>2</a:t>
             </a:r>
             <a:endParaRPr lang="en-US" sz="850" dirty="0"/>
           </a:p>
@@ -3701,9 +4939,6 @@
           <a:bodyPr wrap="square" lIns="0" tIns="0" rIns="0" bIns="0" rtlCol="0" anchor="ctr"/>
           <a:lstStyle/>
           <a:p>
-            <a:pPr marL="0" indent="0">
-              <a:buNone/>
-            </a:pPr>
             <a:r>
               <a:rPr lang="en-US" sz="850" dirty="0">
                 <a:solidFill>
@@ -3713,7 +4948,18 @@
                 <a:ea typeface="Aptos" pitchFamily="34" charset="-122"/>
                 <a:cs typeface="Aptos" pitchFamily="34" charset="-120"/>
               </a:rPr>
-              <a:t>Final Makale/Bildiri Sunumu  •  5/10</a:t>
+              <a:t>Final Makale/Bildiri Sunumu  •  5 /1</a:t>
+            </a:r>
+            <a:r>
+              <a:rPr lang="tr-TR" sz="850" dirty="0">
+                <a:solidFill>
+                  <a:srgbClr val="6B7280"/>
+                </a:solidFill>
+                <a:latin typeface="Aptos" pitchFamily="34" charset="0"/>
+                <a:ea typeface="Aptos" pitchFamily="34" charset="-122"/>
+                <a:cs typeface="Aptos" pitchFamily="34" charset="-120"/>
+              </a:rPr>
+              <a:t>2</a:t>
             </a:r>
             <a:endParaRPr lang="en-US" sz="850" dirty="0"/>
           </a:p>
@@ -4026,7 +5272,29 @@
                 <a:ea typeface="Aptos Display" pitchFamily="34" charset="-122"/>
                 <a:cs typeface="Aptos Display" pitchFamily="34" charset="-120"/>
               </a:rPr>
-              <a:t>5. Bulgular</a:t>
+              <a:t>5. </a:t>
+            </a:r>
+            <a:r>
+              <a:rPr lang="en-US" sz="2400" b="1" dirty="0" err="1">
+                <a:solidFill>
+                  <a:srgbClr val="1E2A5A"/>
+                </a:solidFill>
+                <a:latin typeface="Aptos Display" pitchFamily="34" charset="0"/>
+                <a:ea typeface="Aptos Display" pitchFamily="34" charset="-122"/>
+                <a:cs typeface="Aptos Display" pitchFamily="34" charset="-120"/>
+              </a:rPr>
+              <a:t>Bulgular</a:t>
+            </a:r>
+            <a:r>
+              <a:rPr lang="tr-TR" sz="2400" b="1" dirty="0">
+                <a:solidFill>
+                  <a:srgbClr val="1E2A5A"/>
+                </a:solidFill>
+                <a:latin typeface="Aptos Display" pitchFamily="34" charset="0"/>
+                <a:ea typeface="Aptos Display" pitchFamily="34" charset="-122"/>
+                <a:cs typeface="Aptos Display" pitchFamily="34" charset="-120"/>
+              </a:rPr>
+              <a:t> - 1</a:t>
             </a:r>
             <a:endParaRPr lang="en-US" sz="2400" dirty="0"/>
           </a:p>
@@ -4122,9 +5390,6 @@
           <a:bodyPr wrap="square" lIns="0" tIns="0" rIns="0" bIns="0" rtlCol="0" anchor="ctr"/>
           <a:lstStyle/>
           <a:p>
-            <a:pPr marL="0" indent="0">
-              <a:buNone/>
-            </a:pPr>
             <a:r>
               <a:rPr lang="en-US" sz="850" dirty="0">
                 <a:solidFill>
@@ -4134,38 +5399,10 @@
                 <a:ea typeface="Aptos" pitchFamily="34" charset="-122"/>
                 <a:cs typeface="Aptos" pitchFamily="34" charset="-120"/>
               </a:rPr>
-              <a:t>Final Makale/Bildiri Sunumu  •  6/10</a:t>
-            </a:r>
-            <a:endParaRPr lang="en-US" sz="850" dirty="0"/>
-          </a:p>
-        </p:txBody>
-      </p:sp>
-      <p:sp>
-        <p:nvSpPr>
-          <p:cNvPr id="7" name="Text 5"/>
-          <p:cNvSpPr/>
-          <p:nvPr/>
-        </p:nvSpPr>
-        <p:spPr>
-          <a:xfrm>
-            <a:off x="6995160" y="6510528"/>
-            <a:ext cx="4572000" cy="201168"/>
-          </a:xfrm>
-          <a:prstGeom prst="rect">
-            <a:avLst/>
-          </a:prstGeom>
-          <a:noFill/>
-          <a:ln/>
-        </p:spPr>
-        <p:txBody>
-          <a:bodyPr wrap="square" lIns="0" tIns="0" rIns="0" bIns="0" rtlCol="0" anchor="ctr"/>
-          <a:lstStyle/>
-          <a:p>
-            <a:pPr marL="0" indent="0" algn="r">
-              <a:buNone/>
-            </a:pPr>
-            <a:r>
-              <a:rPr lang="en-US" sz="850" dirty="0">
+              <a:t>Final Makale/Bildiri Sunumu  •  6 /1</a:t>
+            </a:r>
+            <a:r>
+              <a:rPr lang="tr-TR" sz="850" dirty="0">
                 <a:solidFill>
                   <a:srgbClr val="6B7280"/>
                 </a:solidFill>
@@ -4173,6 +5410,45 @@
                 <a:ea typeface="Aptos" pitchFamily="34" charset="-122"/>
                 <a:cs typeface="Aptos" pitchFamily="34" charset="-120"/>
               </a:rPr>
+              <a:t>2</a:t>
+            </a:r>
+            <a:endParaRPr lang="en-US" sz="850" dirty="0"/>
+          </a:p>
+        </p:txBody>
+      </p:sp>
+      <p:sp>
+        <p:nvSpPr>
+          <p:cNvPr id="7" name="Text 5"/>
+          <p:cNvSpPr/>
+          <p:nvPr/>
+        </p:nvSpPr>
+        <p:spPr>
+          <a:xfrm>
+            <a:off x="6995160" y="6510528"/>
+            <a:ext cx="4572000" cy="201168"/>
+          </a:xfrm>
+          <a:prstGeom prst="rect">
+            <a:avLst/>
+          </a:prstGeom>
+          <a:noFill/>
+          <a:ln/>
+        </p:spPr>
+        <p:txBody>
+          <a:bodyPr wrap="square" lIns="0" tIns="0" rIns="0" bIns="0" rtlCol="0" anchor="ctr"/>
+          <a:lstStyle/>
+          <a:p>
+            <a:pPr marL="0" indent="0" algn="r">
+              <a:buNone/>
+            </a:pPr>
+            <a:r>
+              <a:rPr lang="en-US" sz="850" dirty="0">
+                <a:solidFill>
+                  <a:srgbClr val="6B7280"/>
+                </a:solidFill>
+                <a:latin typeface="Aptos" pitchFamily="34" charset="0"/>
+                <a:ea typeface="Aptos" pitchFamily="34" charset="-122"/>
+                <a:cs typeface="Aptos" pitchFamily="34" charset="-120"/>
+              </a:rPr>
               <a:t>İleri Bilgisayarlı Görme ve Derin Öğrenme</a:t>
             </a:r>
             <a:endParaRPr lang="en-US" sz="850" dirty="0"/>
@@ -4202,58 +5478,91 @@
           </a:bodyPr>
           <a:lstStyle/>
           <a:p>
-            <a:r>
-              <a:rPr lang="en-US" sz="1550" dirty="0">
-                <a:solidFill>
-                  <a:srgbClr val="111827"/>
-                </a:solidFill>
-                <a:latin typeface="Aptos" pitchFamily="34" charset="0"/>
-                <a:ea typeface="Aptos" pitchFamily="34" charset="-122"/>
-                <a:cs typeface="Aptos" pitchFamily="34" charset="-120"/>
-              </a:rPr>
-              <a:t>Elde edilen temel performans sonuçları.</a:t>
-            </a:r>
-            <a:endParaRPr lang="en-US" sz="1550" dirty="0"/>
-          </a:p>
-          <a:p>
-            <a:r>
-              <a:rPr lang="en-US" sz="1550" dirty="0">
-                <a:solidFill>
-                  <a:srgbClr val="111827"/>
-                </a:solidFill>
-                <a:latin typeface="Aptos" pitchFamily="34" charset="0"/>
-                <a:ea typeface="Aptos" pitchFamily="34" charset="-122"/>
-                <a:cs typeface="Aptos" pitchFamily="34" charset="-120"/>
-              </a:rPr>
-              <a:t>Eğitim/doğrulama grafikleri veya confusion matrix gibi destekleyici çıktılar.</a:t>
-            </a:r>
-            <a:endParaRPr lang="en-US" sz="1550" dirty="0"/>
-          </a:p>
-          <a:p>
-            <a:r>
-              <a:rPr lang="en-US" sz="1550" dirty="0">
-                <a:solidFill>
-                  <a:srgbClr val="111827"/>
-                </a:solidFill>
-                <a:latin typeface="Aptos" pitchFamily="34" charset="0"/>
-                <a:ea typeface="Aptos" pitchFamily="34" charset="-122"/>
-                <a:cs typeface="Aptos" pitchFamily="34" charset="-120"/>
-              </a:rPr>
-              <a:t>Varsa önceki ödevlerden gelen sonuçlarla birlikte düzenlenmiş karşılaştırma tablosu.</a:t>
-            </a:r>
-            <a:endParaRPr lang="en-US" sz="1550" dirty="0"/>
-          </a:p>
-          <a:p>
-            <a:r>
-              <a:rPr lang="en-US" sz="1550" dirty="0">
-                <a:solidFill>
-                  <a:srgbClr val="111827"/>
-                </a:solidFill>
-                <a:latin typeface="Aptos" pitchFamily="34" charset="0"/>
-                <a:ea typeface="Aptos" pitchFamily="34" charset="-122"/>
-                <a:cs typeface="Aptos" pitchFamily="34" charset="-120"/>
-              </a:rPr>
-              <a:t>Sonuçların yalnızca sayısal değer olarak verilmemesi; kısa yorumla desteklenmesi.</a:t>
+            <a:pPr marL="285750" indent="-285750">
+              <a:buFont typeface="Arial" panose="020B0604020202020204" pitchFamily="34" charset="0"/>
+              <a:buChar char="•"/>
+            </a:pPr>
+            <a:r>
+              <a:rPr lang="tr-TR" sz="1600" dirty="0"/>
+              <a:t>ISIC2019 üzerinde 9 ViT modeli test edildi </a:t>
+            </a:r>
+          </a:p>
+          <a:p>
+            <a:pPr marL="285750" indent="-285750">
+              <a:buFont typeface="Arial" panose="020B0604020202020204" pitchFamily="34" charset="0"/>
+              <a:buChar char="•"/>
+            </a:pPr>
+            <a:r>
+              <a:rPr lang="tr-TR" sz="1600" dirty="0"/>
+              <a:t>En iyi model: </a:t>
+            </a:r>
+            <a:r>
+              <a:rPr lang="tr-TR" sz="1600" b="1" dirty="0"/>
+              <a:t>Swin-Small</a:t>
+            </a:r>
+          </a:p>
+          <a:p>
+            <a:pPr marL="742950" lvl="1" indent="-285750">
+              <a:buFont typeface="Arial" panose="020B0604020202020204" pitchFamily="34" charset="0"/>
+              <a:buChar char="•"/>
+            </a:pPr>
+            <a:r>
+              <a:rPr lang="tr-TR" sz="1600" dirty="0"/>
+              <a:t>Accuracy: </a:t>
+            </a:r>
+            <a:r>
+              <a:rPr lang="tr-TR" sz="1600" b="1" dirty="0"/>
+              <a:t>%88.93</a:t>
+            </a:r>
+            <a:r>
+              <a:rPr lang="tr-TR" sz="1600" dirty="0"/>
+              <a:t> </a:t>
+            </a:r>
+          </a:p>
+          <a:p>
+            <a:pPr marL="742950" lvl="1" indent="-285750">
+              <a:buFont typeface="Arial" panose="020B0604020202020204" pitchFamily="34" charset="0"/>
+              <a:buChar char="•"/>
+            </a:pPr>
+            <a:r>
+              <a:rPr lang="tr-TR" sz="1600" dirty="0"/>
+              <a:t>Macro-F1: </a:t>
+            </a:r>
+            <a:r>
+              <a:rPr lang="tr-TR" sz="1600" b="1" dirty="0"/>
+              <a:t>0.8435</a:t>
+            </a:r>
+            <a:r>
+              <a:rPr lang="tr-TR" sz="1600" dirty="0"/>
+              <a:t> </a:t>
+            </a:r>
+          </a:p>
+          <a:p>
+            <a:pPr marL="285750" indent="-285750">
+              <a:buFont typeface="Arial" panose="020B0604020202020204" pitchFamily="34" charset="0"/>
+              <a:buChar char="•"/>
+            </a:pPr>
+            <a:r>
+              <a:rPr lang="tr-TR" sz="1600" dirty="0"/>
+              <a:t>En zayıf: </a:t>
+            </a:r>
+            <a:r>
+              <a:rPr lang="tr-TR" sz="1600" b="1" dirty="0"/>
+              <a:t>MobileViT-XS</a:t>
+            </a:r>
+            <a:r>
+              <a:rPr lang="tr-TR" sz="1600" dirty="0"/>
+              <a:t> </a:t>
+            </a:r>
+          </a:p>
+          <a:p>
+            <a:pPr marL="285750" indent="-285750">
+              <a:buFont typeface="Arial" panose="020B0604020202020204" pitchFamily="34" charset="0"/>
+              <a:buChar char="•"/>
+            </a:pPr>
+            <a:r>
+              <a:rPr lang="tr-TR" sz="1600" dirty="0"/>
+              <a:t>Genel olarak ViT modelleri güçlü performans gösterdi MEL ↔ NV en çok karışan sınıflar</a:t>
             </a:r>
             <a:endParaRPr lang="en-US" sz="1550" dirty="0"/>
           </a:p>
@@ -4343,6 +5652,876 @@
 </file>
 
 <file path=ppt/slides/slide7.xml><?xml version="1.0" encoding="utf-8"?>
+<p:sld xmlns:a="http://schemas.openxmlformats.org/drawingml/2006/main" xmlns:r="http://schemas.openxmlformats.org/officeDocument/2006/relationships" xmlns:p="http://schemas.openxmlformats.org/presentationml/2006/main">
+  <p:cSld>
+    <p:bg>
+      <p:bgPr>
+        <a:solidFill>
+          <a:srgbClr val="F8FAFC"/>
+        </a:solidFill>
+        <a:effectLst/>
+      </p:bgPr>
+    </p:bg>
+    <p:spTree>
+      <p:nvGrpSpPr>
+        <p:cNvPr id="1" name="">
+          <a:extLst>
+            <a:ext uri="{FF2B5EF4-FFF2-40B4-BE49-F238E27FC236}">
+              <a16:creationId xmlns:a16="http://schemas.microsoft.com/office/drawing/2014/main" id="{6DC11289-9FAE-05D1-69F7-B2D7C7B698F5}"/>
+            </a:ext>
+          </a:extLst>
+        </p:cNvPr>
+        <p:cNvGrpSpPr/>
+        <p:nvPr/>
+      </p:nvGrpSpPr>
+      <p:grpSpPr>
+        <a:xfrm>
+          <a:off x="0" y="0"/>
+          <a:ext cx="0" cy="0"/>
+          <a:chOff x="0" y="0"/>
+          <a:chExt cx="0" cy="0"/>
+        </a:xfrm>
+      </p:grpSpPr>
+      <p:sp>
+        <p:nvSpPr>
+          <p:cNvPr id="2" name="Shape 0">
+            <a:extLst>
+              <a:ext uri="{FF2B5EF4-FFF2-40B4-BE49-F238E27FC236}">
+                <a16:creationId xmlns:a16="http://schemas.microsoft.com/office/drawing/2014/main" id="{7D080AD5-962A-9871-1520-D1AE245D0823}"/>
+              </a:ext>
+            </a:extLst>
+          </p:cNvPr>
+          <p:cNvSpPr/>
+          <p:nvPr/>
+        </p:nvSpPr>
+        <p:spPr>
+          <a:xfrm>
+            <a:off x="0" y="0"/>
+            <a:ext cx="12191695" cy="146304"/>
+          </a:xfrm>
+          <a:prstGeom prst="rect">
+            <a:avLst/>
+          </a:prstGeom>
+          <a:solidFill>
+            <a:srgbClr val="1E2A5A"/>
+          </a:solidFill>
+          <a:ln w="12700">
+            <a:solidFill>
+              <a:srgbClr val="1E2A5A"/>
+            </a:solidFill>
+            <a:prstDash val="solid"/>
+          </a:ln>
+        </p:spPr>
+        <p:txBody>
+          <a:bodyPr/>
+          <a:lstStyle/>
+          <a:p>
+            <a:endParaRPr lang="tr-TR"/>
+          </a:p>
+        </p:txBody>
+      </p:sp>
+      <p:sp>
+        <p:nvSpPr>
+          <p:cNvPr id="3" name="Text 1">
+            <a:extLst>
+              <a:ext uri="{FF2B5EF4-FFF2-40B4-BE49-F238E27FC236}">
+                <a16:creationId xmlns:a16="http://schemas.microsoft.com/office/drawing/2014/main" id="{3AE12428-4462-C0D5-F993-334758C62007}"/>
+              </a:ext>
+            </a:extLst>
+          </p:cNvPr>
+          <p:cNvSpPr/>
+          <p:nvPr/>
+        </p:nvSpPr>
+        <p:spPr>
+          <a:xfrm>
+            <a:off x="594360" y="438912"/>
+            <a:ext cx="8138160" cy="384048"/>
+          </a:xfrm>
+          <a:prstGeom prst="rect">
+            <a:avLst/>
+          </a:prstGeom>
+          <a:noFill/>
+          <a:ln/>
+        </p:spPr>
+        <p:txBody>
+          <a:bodyPr wrap="square" lIns="0" tIns="0" rIns="0" bIns="0" rtlCol="0" anchor="ctr"/>
+          <a:lstStyle/>
+          <a:p>
+            <a:pPr marL="0" indent="0">
+              <a:buNone/>
+            </a:pPr>
+            <a:r>
+              <a:rPr lang="tr-TR" sz="2400" b="1" dirty="0">
+                <a:solidFill>
+                  <a:srgbClr val="1E2A5A"/>
+                </a:solidFill>
+                <a:latin typeface="Aptos Display" pitchFamily="34" charset="0"/>
+                <a:ea typeface="Aptos Display" pitchFamily="34" charset="-122"/>
+                <a:cs typeface="Aptos Display" pitchFamily="34" charset="-120"/>
+              </a:rPr>
+              <a:t>6</a:t>
+            </a:r>
+            <a:r>
+              <a:rPr lang="en-US" sz="2400" b="1" dirty="0">
+                <a:solidFill>
+                  <a:srgbClr val="1E2A5A"/>
+                </a:solidFill>
+                <a:latin typeface="Aptos Display" pitchFamily="34" charset="0"/>
+                <a:ea typeface="Aptos Display" pitchFamily="34" charset="-122"/>
+                <a:cs typeface="Aptos Display" pitchFamily="34" charset="-120"/>
+              </a:rPr>
+              <a:t>. </a:t>
+            </a:r>
+            <a:r>
+              <a:rPr lang="en-US" sz="2400" b="1" dirty="0" err="1">
+                <a:solidFill>
+                  <a:srgbClr val="1E2A5A"/>
+                </a:solidFill>
+                <a:latin typeface="Aptos Display" pitchFamily="34" charset="0"/>
+                <a:ea typeface="Aptos Display" pitchFamily="34" charset="-122"/>
+                <a:cs typeface="Aptos Display" pitchFamily="34" charset="-120"/>
+              </a:rPr>
+              <a:t>Bulgular</a:t>
+            </a:r>
+            <a:r>
+              <a:rPr lang="tr-TR" sz="2400" b="1" dirty="0">
+                <a:solidFill>
+                  <a:srgbClr val="1E2A5A"/>
+                </a:solidFill>
+                <a:latin typeface="Aptos Display" pitchFamily="34" charset="0"/>
+                <a:ea typeface="Aptos Display" pitchFamily="34" charset="-122"/>
+                <a:cs typeface="Aptos Display" pitchFamily="34" charset="-120"/>
+              </a:rPr>
+              <a:t> - 2</a:t>
+            </a:r>
+            <a:endParaRPr lang="en-US" sz="2400" dirty="0"/>
+          </a:p>
+        </p:txBody>
+      </p:sp>
+      <p:sp>
+        <p:nvSpPr>
+          <p:cNvPr id="4" name="Text 2">
+            <a:extLst>
+              <a:ext uri="{FF2B5EF4-FFF2-40B4-BE49-F238E27FC236}">
+                <a16:creationId xmlns:a16="http://schemas.microsoft.com/office/drawing/2014/main" id="{C79FEC7C-5B6E-FD6F-8C23-1AECE0A6EA89}"/>
+              </a:ext>
+            </a:extLst>
+          </p:cNvPr>
+          <p:cNvSpPr/>
+          <p:nvPr/>
+        </p:nvSpPr>
+        <p:spPr>
+          <a:xfrm>
+            <a:off x="612648" y="896112"/>
+            <a:ext cx="9966960" cy="256032"/>
+          </a:xfrm>
+          <a:prstGeom prst="rect">
+            <a:avLst/>
+          </a:prstGeom>
+          <a:noFill/>
+          <a:ln/>
+        </p:spPr>
+        <p:txBody>
+          <a:bodyPr wrap="square" lIns="0" tIns="0" rIns="0" bIns="0" rtlCol="0" anchor="ctr"/>
+          <a:lstStyle/>
+          <a:p>
+            <a:pPr marL="0" indent="0">
+              <a:buNone/>
+            </a:pPr>
+            <a:r>
+              <a:rPr lang="en-US" sz="1050" i="1" dirty="0">
+                <a:solidFill>
+                  <a:srgbClr val="6B7280"/>
+                </a:solidFill>
+                <a:latin typeface="Aptos" pitchFamily="34" charset="0"/>
+                <a:ea typeface="Aptos" pitchFamily="34" charset="-122"/>
+                <a:cs typeface="Aptos" pitchFamily="34" charset="-120"/>
+              </a:rPr>
+              <a:t>Ana sonuçları tablo, grafik veya kısa metinle sunun.</a:t>
+            </a:r>
+            <a:endParaRPr lang="en-US" sz="1050" dirty="0"/>
+          </a:p>
+        </p:txBody>
+      </p:sp>
+      <p:sp>
+        <p:nvSpPr>
+          <p:cNvPr id="5" name="Shape 3">
+            <a:extLst>
+              <a:ext uri="{FF2B5EF4-FFF2-40B4-BE49-F238E27FC236}">
+                <a16:creationId xmlns:a16="http://schemas.microsoft.com/office/drawing/2014/main" id="{DD378D05-A88F-F20A-D78C-D1B4E140FAB9}"/>
+              </a:ext>
+            </a:extLst>
+          </p:cNvPr>
+          <p:cNvSpPr/>
+          <p:nvPr/>
+        </p:nvSpPr>
+        <p:spPr>
+          <a:xfrm>
+            <a:off x="594360" y="1261872"/>
+            <a:ext cx="10972800" cy="0"/>
+          </a:xfrm>
+          <a:prstGeom prst="line">
+            <a:avLst/>
+          </a:prstGeom>
+          <a:noFill/>
+          <a:ln w="9525">
+            <a:solidFill>
+              <a:srgbClr val="CBD5E1"/>
+            </a:solidFill>
+            <a:prstDash val="solid"/>
+          </a:ln>
+        </p:spPr>
+        <p:txBody>
+          <a:bodyPr/>
+          <a:lstStyle/>
+          <a:p>
+            <a:endParaRPr lang="tr-TR"/>
+          </a:p>
+        </p:txBody>
+      </p:sp>
+      <p:sp>
+        <p:nvSpPr>
+          <p:cNvPr id="6" name="Text 4">
+            <a:extLst>
+              <a:ext uri="{FF2B5EF4-FFF2-40B4-BE49-F238E27FC236}">
+                <a16:creationId xmlns:a16="http://schemas.microsoft.com/office/drawing/2014/main" id="{0089F43E-BD9B-79A9-7E81-7DC987CB101D}"/>
+              </a:ext>
+            </a:extLst>
+          </p:cNvPr>
+          <p:cNvSpPr/>
+          <p:nvPr/>
+        </p:nvSpPr>
+        <p:spPr>
+          <a:xfrm>
+            <a:off x="594360" y="6510528"/>
+            <a:ext cx="5029200" cy="201168"/>
+          </a:xfrm>
+          <a:prstGeom prst="rect">
+            <a:avLst/>
+          </a:prstGeom>
+          <a:noFill/>
+          <a:ln/>
+        </p:spPr>
+        <p:txBody>
+          <a:bodyPr wrap="square" lIns="0" tIns="0" rIns="0" bIns="0" rtlCol="0" anchor="ctr"/>
+          <a:lstStyle/>
+          <a:p>
+            <a:r>
+              <a:rPr lang="en-US" sz="850" dirty="0">
+                <a:solidFill>
+                  <a:srgbClr val="6B7280"/>
+                </a:solidFill>
+                <a:latin typeface="Aptos" pitchFamily="34" charset="0"/>
+                <a:ea typeface="Aptos" pitchFamily="34" charset="-122"/>
+                <a:cs typeface="Aptos" pitchFamily="34" charset="-120"/>
+              </a:rPr>
+              <a:t>Final Makale/Bildiri Sunumu  •  </a:t>
+            </a:r>
+            <a:r>
+              <a:rPr lang="tr-TR" sz="850" dirty="0">
+                <a:solidFill>
+                  <a:srgbClr val="6B7280"/>
+                </a:solidFill>
+                <a:latin typeface="Aptos" pitchFamily="34" charset="0"/>
+                <a:ea typeface="Aptos" pitchFamily="34" charset="-122"/>
+                <a:cs typeface="Aptos" pitchFamily="34" charset="-120"/>
+              </a:rPr>
+              <a:t>7</a:t>
+            </a:r>
+            <a:r>
+              <a:rPr lang="en-US" sz="850" dirty="0">
+                <a:solidFill>
+                  <a:srgbClr val="6B7280"/>
+                </a:solidFill>
+                <a:latin typeface="Aptos" pitchFamily="34" charset="0"/>
+                <a:ea typeface="Aptos" pitchFamily="34" charset="-122"/>
+                <a:cs typeface="Aptos" pitchFamily="34" charset="-120"/>
+              </a:rPr>
+              <a:t> /1</a:t>
+            </a:r>
+            <a:r>
+              <a:rPr lang="tr-TR" sz="850" dirty="0">
+                <a:solidFill>
+                  <a:srgbClr val="6B7280"/>
+                </a:solidFill>
+                <a:latin typeface="Aptos" pitchFamily="34" charset="0"/>
+                <a:ea typeface="Aptos" pitchFamily="34" charset="-122"/>
+                <a:cs typeface="Aptos" pitchFamily="34" charset="-120"/>
+              </a:rPr>
+              <a:t>2</a:t>
+            </a:r>
+            <a:endParaRPr lang="en-US" sz="850" dirty="0"/>
+          </a:p>
+        </p:txBody>
+      </p:sp>
+      <p:sp>
+        <p:nvSpPr>
+          <p:cNvPr id="7" name="Text 5">
+            <a:extLst>
+              <a:ext uri="{FF2B5EF4-FFF2-40B4-BE49-F238E27FC236}">
+                <a16:creationId xmlns:a16="http://schemas.microsoft.com/office/drawing/2014/main" id="{63B3E9EA-DE04-0639-310C-D4CE0886807E}"/>
+              </a:ext>
+            </a:extLst>
+          </p:cNvPr>
+          <p:cNvSpPr/>
+          <p:nvPr/>
+        </p:nvSpPr>
+        <p:spPr>
+          <a:xfrm>
+            <a:off x="6995160" y="6510528"/>
+            <a:ext cx="4572000" cy="201168"/>
+          </a:xfrm>
+          <a:prstGeom prst="rect">
+            <a:avLst/>
+          </a:prstGeom>
+          <a:noFill/>
+          <a:ln/>
+        </p:spPr>
+        <p:txBody>
+          <a:bodyPr wrap="square" lIns="0" tIns="0" rIns="0" bIns="0" rtlCol="0" anchor="ctr"/>
+          <a:lstStyle/>
+          <a:p>
+            <a:pPr marL="0" indent="0" algn="r">
+              <a:buNone/>
+            </a:pPr>
+            <a:r>
+              <a:rPr lang="en-US" sz="850" dirty="0">
+                <a:solidFill>
+                  <a:srgbClr val="6B7280"/>
+                </a:solidFill>
+                <a:latin typeface="Aptos" pitchFamily="34" charset="0"/>
+                <a:ea typeface="Aptos" pitchFamily="34" charset="-122"/>
+                <a:cs typeface="Aptos" pitchFamily="34" charset="-120"/>
+              </a:rPr>
+              <a:t>İleri Bilgisayarlı Görme ve Derin Öğrenme</a:t>
+            </a:r>
+            <a:endParaRPr lang="en-US" sz="850" dirty="0"/>
+          </a:p>
+        </p:txBody>
+      </p:sp>
+      <p:sp>
+        <p:nvSpPr>
+          <p:cNvPr id="8" name="Text 6">
+            <a:extLst>
+              <a:ext uri="{FF2B5EF4-FFF2-40B4-BE49-F238E27FC236}">
+                <a16:creationId xmlns:a16="http://schemas.microsoft.com/office/drawing/2014/main" id="{1D2F096B-46BB-6999-B0E2-4FA54F284F3E}"/>
+              </a:ext>
+            </a:extLst>
+          </p:cNvPr>
+          <p:cNvSpPr/>
+          <p:nvPr/>
+        </p:nvSpPr>
+        <p:spPr>
+          <a:xfrm>
+            <a:off x="749808" y="1600200"/>
+            <a:ext cx="10378440" cy="3200400"/>
+          </a:xfrm>
+          <a:prstGeom prst="rect">
+            <a:avLst/>
+          </a:prstGeom>
+          <a:noFill/>
+          <a:ln/>
+        </p:spPr>
+        <p:txBody>
+          <a:bodyPr wrap="square" lIns="254" tIns="254" rIns="254" bIns="254" rtlCol="0" anchor="ctr">
+            <a:normAutofit/>
+          </a:bodyPr>
+          <a:lstStyle/>
+          <a:p>
+            <a:endParaRPr lang="en-US" sz="1550" dirty="0"/>
+          </a:p>
+        </p:txBody>
+      </p:sp>
+      <p:pic>
+        <p:nvPicPr>
+          <p:cNvPr id="11" name="Picture 10">
+            <a:extLst>
+              <a:ext uri="{FF2B5EF4-FFF2-40B4-BE49-F238E27FC236}">
+                <a16:creationId xmlns:a16="http://schemas.microsoft.com/office/drawing/2014/main" id="{F3842B5A-D022-4B27-2F71-EC37951C9269}"/>
+              </a:ext>
+            </a:extLst>
+          </p:cNvPr>
+          <p:cNvPicPr>
+            <a:picLocks noChangeAspect="1"/>
+          </p:cNvPicPr>
+          <p:nvPr/>
+        </p:nvPicPr>
+        <p:blipFill>
+          <a:blip r:embed="rId3"/>
+          <a:stretch>
+            <a:fillRect/>
+          </a:stretch>
+        </p:blipFill>
+        <p:spPr>
+          <a:xfrm>
+            <a:off x="612648" y="1381434"/>
+            <a:ext cx="6581782" cy="4907036"/>
+          </a:xfrm>
+          <a:prstGeom prst="rect">
+            <a:avLst/>
+          </a:prstGeom>
+        </p:spPr>
+      </p:pic>
+    </p:spTree>
+    <p:extLst>
+      <p:ext uri="{BB962C8B-B14F-4D97-AF65-F5344CB8AC3E}">
+        <p14:creationId xmlns:p14="http://schemas.microsoft.com/office/powerpoint/2010/main" val="2593739947"/>
+      </p:ext>
+    </p:extLst>
+  </p:cSld>
+  <p:clrMapOvr>
+    <a:masterClrMapping/>
+  </p:clrMapOvr>
+</p:sld>
+</file>
+
+<file path=ppt/slides/slide8.xml><?xml version="1.0" encoding="utf-8"?>
+<p:sld xmlns:a="http://schemas.openxmlformats.org/drawingml/2006/main" xmlns:r="http://schemas.openxmlformats.org/officeDocument/2006/relationships" xmlns:p="http://schemas.openxmlformats.org/presentationml/2006/main">
+  <p:cSld>
+    <p:bg>
+      <p:bgPr>
+        <a:solidFill>
+          <a:srgbClr val="F8FAFC"/>
+        </a:solidFill>
+        <a:effectLst/>
+      </p:bgPr>
+    </p:bg>
+    <p:spTree>
+      <p:nvGrpSpPr>
+        <p:cNvPr id="1" name="">
+          <a:extLst>
+            <a:ext uri="{FF2B5EF4-FFF2-40B4-BE49-F238E27FC236}">
+              <a16:creationId xmlns:a16="http://schemas.microsoft.com/office/drawing/2014/main" id="{4E5AB49D-CA84-1A43-1FF6-76522EA96451}"/>
+            </a:ext>
+          </a:extLst>
+        </p:cNvPr>
+        <p:cNvGrpSpPr/>
+        <p:nvPr/>
+      </p:nvGrpSpPr>
+      <p:grpSpPr>
+        <a:xfrm>
+          <a:off x="0" y="0"/>
+          <a:ext cx="0" cy="0"/>
+          <a:chOff x="0" y="0"/>
+          <a:chExt cx="0" cy="0"/>
+        </a:xfrm>
+      </p:grpSpPr>
+      <p:sp>
+        <p:nvSpPr>
+          <p:cNvPr id="2" name="Shape 0">
+            <a:extLst>
+              <a:ext uri="{FF2B5EF4-FFF2-40B4-BE49-F238E27FC236}">
+                <a16:creationId xmlns:a16="http://schemas.microsoft.com/office/drawing/2014/main" id="{353DCE8E-F538-0594-DBA3-FFF5D1F2DFA5}"/>
+              </a:ext>
+            </a:extLst>
+          </p:cNvPr>
+          <p:cNvSpPr/>
+          <p:nvPr/>
+        </p:nvSpPr>
+        <p:spPr>
+          <a:xfrm>
+            <a:off x="0" y="0"/>
+            <a:ext cx="12191695" cy="146304"/>
+          </a:xfrm>
+          <a:prstGeom prst="rect">
+            <a:avLst/>
+          </a:prstGeom>
+          <a:solidFill>
+            <a:srgbClr val="1E2A5A"/>
+          </a:solidFill>
+          <a:ln w="12700">
+            <a:solidFill>
+              <a:srgbClr val="1E2A5A"/>
+            </a:solidFill>
+            <a:prstDash val="solid"/>
+          </a:ln>
+        </p:spPr>
+        <p:txBody>
+          <a:bodyPr/>
+          <a:lstStyle/>
+          <a:p>
+            <a:endParaRPr lang="tr-TR"/>
+          </a:p>
+        </p:txBody>
+      </p:sp>
+      <p:sp>
+        <p:nvSpPr>
+          <p:cNvPr id="3" name="Text 1">
+            <a:extLst>
+              <a:ext uri="{FF2B5EF4-FFF2-40B4-BE49-F238E27FC236}">
+                <a16:creationId xmlns:a16="http://schemas.microsoft.com/office/drawing/2014/main" id="{0420AA58-E412-3F69-16BD-90B602B12AE3}"/>
+              </a:ext>
+            </a:extLst>
+          </p:cNvPr>
+          <p:cNvSpPr/>
+          <p:nvPr/>
+        </p:nvSpPr>
+        <p:spPr>
+          <a:xfrm>
+            <a:off x="594360" y="438912"/>
+            <a:ext cx="8138160" cy="384048"/>
+          </a:xfrm>
+          <a:prstGeom prst="rect">
+            <a:avLst/>
+          </a:prstGeom>
+          <a:noFill/>
+          <a:ln/>
+        </p:spPr>
+        <p:txBody>
+          <a:bodyPr wrap="square" lIns="0" tIns="0" rIns="0" bIns="0" rtlCol="0" anchor="ctr"/>
+          <a:lstStyle/>
+          <a:p>
+            <a:pPr marL="0" indent="0">
+              <a:buNone/>
+            </a:pPr>
+            <a:r>
+              <a:rPr lang="tr-TR" sz="2400" b="1" dirty="0">
+                <a:solidFill>
+                  <a:srgbClr val="1E2A5A"/>
+                </a:solidFill>
+                <a:latin typeface="Aptos Display" pitchFamily="34" charset="0"/>
+                <a:ea typeface="Aptos Display" pitchFamily="34" charset="-122"/>
+                <a:cs typeface="Aptos Display" pitchFamily="34" charset="-120"/>
+              </a:rPr>
+              <a:t>7</a:t>
+            </a:r>
+            <a:r>
+              <a:rPr lang="en-US" sz="2400" b="1" dirty="0">
+                <a:solidFill>
+                  <a:srgbClr val="1E2A5A"/>
+                </a:solidFill>
+                <a:latin typeface="Aptos Display" pitchFamily="34" charset="0"/>
+                <a:ea typeface="Aptos Display" pitchFamily="34" charset="-122"/>
+                <a:cs typeface="Aptos Display" pitchFamily="34" charset="-120"/>
+              </a:rPr>
+              <a:t>. </a:t>
+            </a:r>
+            <a:r>
+              <a:rPr lang="en-US" sz="2400" b="1" dirty="0" err="1">
+                <a:solidFill>
+                  <a:srgbClr val="1E2A5A"/>
+                </a:solidFill>
+                <a:latin typeface="Aptos Display" pitchFamily="34" charset="0"/>
+                <a:ea typeface="Aptos Display" pitchFamily="34" charset="-122"/>
+                <a:cs typeface="Aptos Display" pitchFamily="34" charset="-120"/>
+              </a:rPr>
+              <a:t>Bulgular</a:t>
+            </a:r>
+            <a:r>
+              <a:rPr lang="tr-TR" sz="2400" b="1" dirty="0">
+                <a:solidFill>
+                  <a:srgbClr val="1E2A5A"/>
+                </a:solidFill>
+                <a:latin typeface="Aptos Display" pitchFamily="34" charset="0"/>
+                <a:ea typeface="Aptos Display" pitchFamily="34" charset="-122"/>
+                <a:cs typeface="Aptos Display" pitchFamily="34" charset="-120"/>
+              </a:rPr>
+              <a:t> - 3</a:t>
+            </a:r>
+            <a:endParaRPr lang="en-US" sz="2400" dirty="0"/>
+          </a:p>
+        </p:txBody>
+      </p:sp>
+      <p:sp>
+        <p:nvSpPr>
+          <p:cNvPr id="4" name="Text 2">
+            <a:extLst>
+              <a:ext uri="{FF2B5EF4-FFF2-40B4-BE49-F238E27FC236}">
+                <a16:creationId xmlns:a16="http://schemas.microsoft.com/office/drawing/2014/main" id="{45553BDB-A2CE-DD4D-2673-4B2264A21CA9}"/>
+              </a:ext>
+            </a:extLst>
+          </p:cNvPr>
+          <p:cNvSpPr/>
+          <p:nvPr/>
+        </p:nvSpPr>
+        <p:spPr>
+          <a:xfrm>
+            <a:off x="612648" y="896112"/>
+            <a:ext cx="9966960" cy="256032"/>
+          </a:xfrm>
+          <a:prstGeom prst="rect">
+            <a:avLst/>
+          </a:prstGeom>
+          <a:noFill/>
+          <a:ln/>
+        </p:spPr>
+        <p:txBody>
+          <a:bodyPr wrap="square" lIns="0" tIns="0" rIns="0" bIns="0" rtlCol="0" anchor="ctr"/>
+          <a:lstStyle/>
+          <a:p>
+            <a:pPr marL="0" indent="0">
+              <a:buNone/>
+            </a:pPr>
+            <a:r>
+              <a:rPr lang="en-US" sz="1050" i="1" dirty="0">
+                <a:solidFill>
+                  <a:srgbClr val="6B7280"/>
+                </a:solidFill>
+                <a:latin typeface="Aptos" pitchFamily="34" charset="0"/>
+                <a:ea typeface="Aptos" pitchFamily="34" charset="-122"/>
+                <a:cs typeface="Aptos" pitchFamily="34" charset="-120"/>
+              </a:rPr>
+              <a:t>Ana sonuçları tablo, grafik veya kısa metinle sunun.</a:t>
+            </a:r>
+            <a:endParaRPr lang="en-US" sz="1050" dirty="0"/>
+          </a:p>
+        </p:txBody>
+      </p:sp>
+      <p:sp>
+        <p:nvSpPr>
+          <p:cNvPr id="5" name="Shape 3">
+            <a:extLst>
+              <a:ext uri="{FF2B5EF4-FFF2-40B4-BE49-F238E27FC236}">
+                <a16:creationId xmlns:a16="http://schemas.microsoft.com/office/drawing/2014/main" id="{1988580B-2608-9DDA-4230-9DEC7F3582F3}"/>
+              </a:ext>
+            </a:extLst>
+          </p:cNvPr>
+          <p:cNvSpPr/>
+          <p:nvPr/>
+        </p:nvSpPr>
+        <p:spPr>
+          <a:xfrm>
+            <a:off x="594360" y="1261872"/>
+            <a:ext cx="10972800" cy="0"/>
+          </a:xfrm>
+          <a:prstGeom prst="line">
+            <a:avLst/>
+          </a:prstGeom>
+          <a:noFill/>
+          <a:ln w="9525">
+            <a:solidFill>
+              <a:srgbClr val="CBD5E1"/>
+            </a:solidFill>
+            <a:prstDash val="solid"/>
+          </a:ln>
+        </p:spPr>
+        <p:txBody>
+          <a:bodyPr/>
+          <a:lstStyle/>
+          <a:p>
+            <a:endParaRPr lang="tr-TR"/>
+          </a:p>
+        </p:txBody>
+      </p:sp>
+      <p:sp>
+        <p:nvSpPr>
+          <p:cNvPr id="6" name="Text 4">
+            <a:extLst>
+              <a:ext uri="{FF2B5EF4-FFF2-40B4-BE49-F238E27FC236}">
+                <a16:creationId xmlns:a16="http://schemas.microsoft.com/office/drawing/2014/main" id="{D49A2D7D-FD4A-92C8-922D-47080B193A2D}"/>
+              </a:ext>
+            </a:extLst>
+          </p:cNvPr>
+          <p:cNvSpPr/>
+          <p:nvPr/>
+        </p:nvSpPr>
+        <p:spPr>
+          <a:xfrm>
+            <a:off x="594360" y="6510528"/>
+            <a:ext cx="5029200" cy="201168"/>
+          </a:xfrm>
+          <a:prstGeom prst="rect">
+            <a:avLst/>
+          </a:prstGeom>
+          <a:noFill/>
+          <a:ln/>
+        </p:spPr>
+        <p:txBody>
+          <a:bodyPr wrap="square" lIns="0" tIns="0" rIns="0" bIns="0" rtlCol="0" anchor="ctr"/>
+          <a:lstStyle/>
+          <a:p>
+            <a:r>
+              <a:rPr lang="en-US" sz="850" dirty="0">
+                <a:solidFill>
+                  <a:srgbClr val="6B7280"/>
+                </a:solidFill>
+                <a:latin typeface="Aptos" pitchFamily="34" charset="0"/>
+                <a:ea typeface="Aptos" pitchFamily="34" charset="-122"/>
+                <a:cs typeface="Aptos" pitchFamily="34" charset="-120"/>
+              </a:rPr>
+              <a:t>Final Makale/Bildiri </a:t>
+            </a:r>
+            <a:r>
+              <a:rPr lang="en-US" sz="850" dirty="0" err="1">
+                <a:solidFill>
+                  <a:srgbClr val="6B7280"/>
+                </a:solidFill>
+                <a:latin typeface="Aptos" pitchFamily="34" charset="0"/>
+                <a:ea typeface="Aptos" pitchFamily="34" charset="-122"/>
+                <a:cs typeface="Aptos" pitchFamily="34" charset="-120"/>
+              </a:rPr>
+              <a:t>Sunumu</a:t>
+            </a:r>
+            <a:r>
+              <a:rPr lang="en-US" sz="850" dirty="0">
+                <a:solidFill>
+                  <a:srgbClr val="6B7280"/>
+                </a:solidFill>
+                <a:latin typeface="Aptos" pitchFamily="34" charset="0"/>
+                <a:ea typeface="Aptos" pitchFamily="34" charset="-122"/>
+                <a:cs typeface="Aptos" pitchFamily="34" charset="-120"/>
+              </a:rPr>
+              <a:t>  •  </a:t>
+            </a:r>
+            <a:r>
+              <a:rPr lang="tr-TR" sz="850" dirty="0">
+                <a:solidFill>
+                  <a:srgbClr val="6B7280"/>
+                </a:solidFill>
+                <a:latin typeface="Aptos" pitchFamily="34" charset="0"/>
+                <a:ea typeface="Aptos" pitchFamily="34" charset="-122"/>
+                <a:cs typeface="Aptos" pitchFamily="34" charset="-120"/>
+              </a:rPr>
+              <a:t>8</a:t>
+            </a:r>
+            <a:r>
+              <a:rPr lang="en-US" sz="850" dirty="0">
+                <a:solidFill>
+                  <a:srgbClr val="6B7280"/>
+                </a:solidFill>
+                <a:latin typeface="Aptos" pitchFamily="34" charset="0"/>
+                <a:ea typeface="Aptos" pitchFamily="34" charset="-122"/>
+                <a:cs typeface="Aptos" pitchFamily="34" charset="-120"/>
+              </a:rPr>
+              <a:t> /1</a:t>
+            </a:r>
+            <a:r>
+              <a:rPr lang="tr-TR" sz="850" dirty="0">
+                <a:solidFill>
+                  <a:srgbClr val="6B7280"/>
+                </a:solidFill>
+                <a:latin typeface="Aptos" pitchFamily="34" charset="0"/>
+                <a:ea typeface="Aptos" pitchFamily="34" charset="-122"/>
+                <a:cs typeface="Aptos" pitchFamily="34" charset="-120"/>
+              </a:rPr>
+              <a:t>2</a:t>
+            </a:r>
+            <a:endParaRPr lang="en-US" sz="850" dirty="0"/>
+          </a:p>
+        </p:txBody>
+      </p:sp>
+      <p:sp>
+        <p:nvSpPr>
+          <p:cNvPr id="7" name="Text 5">
+            <a:extLst>
+              <a:ext uri="{FF2B5EF4-FFF2-40B4-BE49-F238E27FC236}">
+                <a16:creationId xmlns:a16="http://schemas.microsoft.com/office/drawing/2014/main" id="{544ABDEA-16A7-29BB-1E55-0C1DD466B77F}"/>
+              </a:ext>
+            </a:extLst>
+          </p:cNvPr>
+          <p:cNvSpPr/>
+          <p:nvPr/>
+        </p:nvSpPr>
+        <p:spPr>
+          <a:xfrm>
+            <a:off x="6995160" y="6510528"/>
+            <a:ext cx="4572000" cy="201168"/>
+          </a:xfrm>
+          <a:prstGeom prst="rect">
+            <a:avLst/>
+          </a:prstGeom>
+          <a:noFill/>
+          <a:ln/>
+        </p:spPr>
+        <p:txBody>
+          <a:bodyPr wrap="square" lIns="0" tIns="0" rIns="0" bIns="0" rtlCol="0" anchor="ctr"/>
+          <a:lstStyle/>
+          <a:p>
+            <a:pPr marL="0" indent="0" algn="r">
+              <a:buNone/>
+            </a:pPr>
+            <a:r>
+              <a:rPr lang="en-US" sz="850" dirty="0">
+                <a:solidFill>
+                  <a:srgbClr val="6B7280"/>
+                </a:solidFill>
+                <a:latin typeface="Aptos" pitchFamily="34" charset="0"/>
+                <a:ea typeface="Aptos" pitchFamily="34" charset="-122"/>
+                <a:cs typeface="Aptos" pitchFamily="34" charset="-120"/>
+              </a:rPr>
+              <a:t>İleri Bilgisayarlı Görme ve Derin Öğrenme</a:t>
+            </a:r>
+            <a:endParaRPr lang="en-US" sz="850" dirty="0"/>
+          </a:p>
+        </p:txBody>
+      </p:sp>
+      <p:sp>
+        <p:nvSpPr>
+          <p:cNvPr id="8" name="Text 6">
+            <a:extLst>
+              <a:ext uri="{FF2B5EF4-FFF2-40B4-BE49-F238E27FC236}">
+                <a16:creationId xmlns:a16="http://schemas.microsoft.com/office/drawing/2014/main" id="{B7C0B6D9-AD74-9BC0-8717-9F53A3116C75}"/>
+              </a:ext>
+            </a:extLst>
+          </p:cNvPr>
+          <p:cNvSpPr/>
+          <p:nvPr/>
+        </p:nvSpPr>
+        <p:spPr>
+          <a:xfrm>
+            <a:off x="749808" y="1600200"/>
+            <a:ext cx="10378440" cy="3200400"/>
+          </a:xfrm>
+          <a:prstGeom prst="rect">
+            <a:avLst/>
+          </a:prstGeom>
+          <a:noFill/>
+          <a:ln/>
+        </p:spPr>
+        <p:txBody>
+          <a:bodyPr wrap="square" lIns="254" tIns="254" rIns="254" bIns="254" rtlCol="0" anchor="ctr">
+            <a:normAutofit/>
+          </a:bodyPr>
+          <a:lstStyle/>
+          <a:p>
+            <a:endParaRPr lang="en-US" sz="1550" dirty="0"/>
+          </a:p>
+        </p:txBody>
+      </p:sp>
+      <p:pic>
+        <p:nvPicPr>
+          <p:cNvPr id="9" name="Picture 8">
+            <a:extLst>
+              <a:ext uri="{FF2B5EF4-FFF2-40B4-BE49-F238E27FC236}">
+                <a16:creationId xmlns:a16="http://schemas.microsoft.com/office/drawing/2014/main" id="{6D511F52-43A0-DAFD-E0DA-71500BA05D66}"/>
+              </a:ext>
+            </a:extLst>
+          </p:cNvPr>
+          <p:cNvPicPr>
+            <a:picLocks noChangeAspect="1"/>
+          </p:cNvPicPr>
+          <p:nvPr/>
+        </p:nvPicPr>
+        <p:blipFill>
+          <a:blip r:embed="rId3"/>
+          <a:stretch>
+            <a:fillRect/>
+          </a:stretch>
+        </p:blipFill>
+        <p:spPr>
+          <a:xfrm>
+            <a:off x="612648" y="1369701"/>
+            <a:ext cx="9859820" cy="4970790"/>
+          </a:xfrm>
+          <a:prstGeom prst="rect">
+            <a:avLst/>
+          </a:prstGeom>
+        </p:spPr>
+      </p:pic>
+    </p:spTree>
+    <p:extLst>
+      <p:ext uri="{BB962C8B-B14F-4D97-AF65-F5344CB8AC3E}">
+        <p14:creationId xmlns:p14="http://schemas.microsoft.com/office/powerpoint/2010/main" val="2312415918"/>
+      </p:ext>
+    </p:extLst>
+  </p:cSld>
+  <p:clrMapOvr>
+    <a:masterClrMapping/>
+  </p:clrMapOvr>
+</p:sld>
+</file>
+
+<file path=ppt/slides/slide9.xml><?xml version="1.0" encoding="utf-8"?>
 <p:sld xmlns:a="http://schemas.openxmlformats.org/drawingml/2006/main" xmlns:r="http://schemas.openxmlformats.org/officeDocument/2006/relationships" xmlns:p="http://schemas.openxmlformats.org/presentationml/2006/main">
   <p:cSld name="Slide 7">
     <p:bg>
@@ -4424,7 +6603,7 @@
               <a:buNone/>
             </a:pPr>
             <a:r>
-              <a:rPr lang="en-US" sz="2400" b="1" dirty="0">
+              <a:rPr lang="tr-TR" sz="2400" b="1" dirty="0">
                 <a:solidFill>
                   <a:srgbClr val="1E2A5A"/>
                 </a:solidFill>
@@ -4432,7 +6611,18 @@
                 <a:ea typeface="Aptos Display" pitchFamily="34" charset="-122"/>
                 <a:cs typeface="Aptos Display" pitchFamily="34" charset="-120"/>
               </a:rPr>
-              <a:t>6. Analiz ve Yorum</a:t>
+              <a:t>8</a:t>
+            </a:r>
+            <a:r>
+              <a:rPr lang="en-US" sz="2400" b="1" dirty="0">
+                <a:solidFill>
+                  <a:srgbClr val="1E2A5A"/>
+                </a:solidFill>
+                <a:latin typeface="Aptos Display" pitchFamily="34" charset="0"/>
+                <a:ea typeface="Aptos Display" pitchFamily="34" charset="-122"/>
+                <a:cs typeface="Aptos Display" pitchFamily="34" charset="-120"/>
+              </a:rPr>
+              <a:t>. Analiz ve Yorum</a:t>
             </a:r>
             <a:endParaRPr lang="en-US" sz="2400" dirty="0"/>
           </a:p>
@@ -4528,9 +6718,6 @@
           <a:bodyPr wrap="square" lIns="0" tIns="0" rIns="0" bIns="0" rtlCol="0" anchor="ctr"/>
           <a:lstStyle/>
           <a:p>
-            <a:pPr marL="0" indent="0">
-              <a:buNone/>
-            </a:pPr>
             <a:r>
               <a:rPr lang="en-US" sz="850" dirty="0">
                 <a:solidFill>
@@ -4540,38 +6727,10 @@
                 <a:ea typeface="Aptos" pitchFamily="34" charset="-122"/>
                 <a:cs typeface="Aptos" pitchFamily="34" charset="-120"/>
               </a:rPr>
-              <a:t>Final Makale/Bildiri Sunumu  •  7/10</a:t>
-            </a:r>
-            <a:endParaRPr lang="en-US" sz="850" dirty="0"/>
-          </a:p>
-        </p:txBody>
-      </p:sp>
-      <p:sp>
-        <p:nvSpPr>
-          <p:cNvPr id="7" name="Text 5"/>
-          <p:cNvSpPr/>
-          <p:nvPr/>
-        </p:nvSpPr>
-        <p:spPr>
-          <a:xfrm>
-            <a:off x="6995160" y="6510528"/>
-            <a:ext cx="4572000" cy="201168"/>
-          </a:xfrm>
-          <a:prstGeom prst="rect">
-            <a:avLst/>
-          </a:prstGeom>
-          <a:noFill/>
-          <a:ln/>
-        </p:spPr>
-        <p:txBody>
-          <a:bodyPr wrap="square" lIns="0" tIns="0" rIns="0" bIns="0" rtlCol="0" anchor="ctr"/>
-          <a:lstStyle/>
-          <a:p>
-            <a:pPr marL="0" indent="0" algn="r">
-              <a:buNone/>
-            </a:pPr>
-            <a:r>
-              <a:rPr lang="en-US" sz="850" dirty="0">
+              <a:t>Final Makale/Bildiri Sunumu  •  </a:t>
+            </a:r>
+            <a:r>
+              <a:rPr lang="tr-TR" sz="850" dirty="0">
                 <a:solidFill>
                   <a:srgbClr val="6B7280"/>
                 </a:solidFill>
@@ -4579,6 +6738,67 @@
                 <a:ea typeface="Aptos" pitchFamily="34" charset="-122"/>
                 <a:cs typeface="Aptos" pitchFamily="34" charset="-120"/>
               </a:rPr>
+              <a:t>9</a:t>
+            </a:r>
+            <a:r>
+              <a:rPr lang="en-US" sz="850" dirty="0">
+                <a:solidFill>
+                  <a:srgbClr val="6B7280"/>
+                </a:solidFill>
+                <a:latin typeface="Aptos" pitchFamily="34" charset="0"/>
+                <a:ea typeface="Aptos" pitchFamily="34" charset="-122"/>
+                <a:cs typeface="Aptos" pitchFamily="34" charset="-120"/>
+              </a:rPr>
+              <a:t> /1</a:t>
+            </a:r>
+            <a:r>
+              <a:rPr lang="tr-TR" sz="850" dirty="0">
+                <a:solidFill>
+                  <a:srgbClr val="6B7280"/>
+                </a:solidFill>
+                <a:latin typeface="Aptos" pitchFamily="34" charset="0"/>
+                <a:ea typeface="Aptos" pitchFamily="34" charset="-122"/>
+                <a:cs typeface="Aptos" pitchFamily="34" charset="-120"/>
+              </a:rPr>
+              <a:t>2</a:t>
+            </a:r>
+            <a:endParaRPr lang="en-US" sz="850" dirty="0"/>
+          </a:p>
+        </p:txBody>
+      </p:sp>
+      <p:sp>
+        <p:nvSpPr>
+          <p:cNvPr id="7" name="Text 5"/>
+          <p:cNvSpPr/>
+          <p:nvPr/>
+        </p:nvSpPr>
+        <p:spPr>
+          <a:xfrm>
+            <a:off x="6995160" y="6510528"/>
+            <a:ext cx="4572000" cy="201168"/>
+          </a:xfrm>
+          <a:prstGeom prst="rect">
+            <a:avLst/>
+          </a:prstGeom>
+          <a:noFill/>
+          <a:ln/>
+        </p:spPr>
+        <p:txBody>
+          <a:bodyPr wrap="square" lIns="0" tIns="0" rIns="0" bIns="0" rtlCol="0" anchor="ctr"/>
+          <a:lstStyle/>
+          <a:p>
+            <a:pPr marL="0" indent="0" algn="r">
+              <a:buNone/>
+            </a:pPr>
+            <a:r>
+              <a:rPr lang="en-US" sz="850" dirty="0">
+                <a:solidFill>
+                  <a:srgbClr val="6B7280"/>
+                </a:solidFill>
+                <a:latin typeface="Aptos" pitchFamily="34" charset="0"/>
+                <a:ea typeface="Aptos" pitchFamily="34" charset="-122"/>
+                <a:cs typeface="Aptos" pitchFamily="34" charset="-120"/>
+              </a:rPr>
               <a:t>İleri Bilgisayarlı Görme ve Derin Öğrenme</a:t>
             </a:r>
             <a:endParaRPr lang="en-US" sz="850" dirty="0"/>
@@ -4608,60 +6828,34 @@
           </a:bodyPr>
           <a:lstStyle/>
           <a:p>
-            <a:r>
-              <a:rPr lang="en-US" sz="1550" dirty="0">
-                <a:solidFill>
-                  <a:srgbClr val="111827"/>
-                </a:solidFill>
-                <a:latin typeface="Aptos" pitchFamily="34" charset="0"/>
-                <a:ea typeface="Aptos" pitchFamily="34" charset="-122"/>
-                <a:cs typeface="Aptos" pitchFamily="34" charset="-120"/>
-              </a:rPr>
-              <a:t>Seçtiğiniz ana karşılaştırma veya analiz ne gösteriyor?</a:t>
-            </a:r>
-            <a:endParaRPr lang="en-US" sz="1550" dirty="0"/>
-          </a:p>
-          <a:p>
-            <a:r>
-              <a:rPr lang="en-US" sz="1550" dirty="0">
-                <a:solidFill>
-                  <a:srgbClr val="111827"/>
-                </a:solidFill>
-                <a:latin typeface="Aptos" pitchFamily="34" charset="0"/>
-                <a:ea typeface="Aptos" pitchFamily="34" charset="-122"/>
-                <a:cs typeface="Aptos" pitchFamily="34" charset="-120"/>
-              </a:rPr>
-              <a:t>Sonuçlardaki artış, düşüş veya farkların olası nedenleri nelerdir?</a:t>
-            </a:r>
-            <a:endParaRPr lang="en-US" sz="1550" dirty="0"/>
-          </a:p>
-          <a:p>
-            <a:r>
-              <a:rPr lang="en-US" sz="1550" dirty="0">
-                <a:solidFill>
-                  <a:srgbClr val="111827"/>
-                </a:solidFill>
-                <a:latin typeface="Aptos" pitchFamily="34" charset="0"/>
-                <a:ea typeface="Aptos" pitchFamily="34" charset="-122"/>
-                <a:cs typeface="Aptos" pitchFamily="34" charset="-120"/>
-              </a:rPr>
-              <a:t>Performans, eğitim süresi, veri zorluğu veya model seçimi arasında nasıl bir denge var?</a:t>
-            </a:r>
-            <a:endParaRPr lang="en-US" sz="1550" dirty="0"/>
-          </a:p>
-          <a:p>
-            <a:r>
-              <a:rPr lang="en-US" sz="1550" dirty="0">
-                <a:solidFill>
-                  <a:srgbClr val="111827"/>
-                </a:solidFill>
-                <a:latin typeface="Aptos" pitchFamily="34" charset="0"/>
-                <a:ea typeface="Aptos" pitchFamily="34" charset="-122"/>
-                <a:cs typeface="Aptos" pitchFamily="34" charset="-120"/>
-              </a:rPr>
-              <a:t>Hata analizi yapılmışsa, en çok karışan sınıflar ve muhtemel nedenler.</a:t>
-            </a:r>
-            <a:endParaRPr lang="en-US" sz="1550" dirty="0"/>
+            <a:pPr marL="285750" indent="-285750">
+              <a:buFont typeface="Arial" panose="020B0604020202020204" pitchFamily="34" charset="0"/>
+              <a:buChar char="•"/>
+            </a:pPr>
+            <a:r>
+              <a:rPr lang="tr-TR" sz="1600" dirty="0"/>
+              <a:t>Swin-Small başarısı: Hiyerarşik attention → daha iyi genelleme </a:t>
+            </a:r>
+          </a:p>
+          <a:p>
+            <a:pPr marL="285750" indent="-285750">
+              <a:buFont typeface="Arial" panose="020B0604020202020204" pitchFamily="34" charset="0"/>
+              <a:buChar char="•"/>
+            </a:pPr>
+            <a:r>
+              <a:rPr lang="tr-TR" sz="1600" dirty="0"/>
+              <a:t>MobileViT düşük performans: Mobil odaklı → düşük temsil kapasitesi (en düşük GAP) </a:t>
+            </a:r>
+          </a:p>
+          <a:p>
+            <a:pPr marL="285750" indent="-285750">
+              <a:buFont typeface="Arial" panose="020B0604020202020204" pitchFamily="34" charset="0"/>
+              <a:buChar char="•"/>
+            </a:pPr>
+            <a:r>
+              <a:rPr lang="tr-TR" sz="1600" dirty="0"/>
+              <a:t>MaxViT / ViT / DeiT: Dengeli ama Swin kadar güçlü değil</a:t>
+            </a:r>
           </a:p>
         </p:txBody>
       </p:sp>
@@ -4735,818 +6929,6 @@
                 <a:cs typeface="Aptos" pitchFamily="34" charset="-120"/>
               </a:rPr>
               <a:t>Buradaki maddeler örnektir; çalışmanızın türüne göre uygun olanları kullanın.</a:t>
-            </a:r>
-            <a:endParaRPr lang="en-US" sz="1200" dirty="0"/>
-          </a:p>
-        </p:txBody>
-      </p:sp>
-    </p:spTree>
-  </p:cSld>
-  <p:clrMapOvr>
-    <a:masterClrMapping/>
-  </p:clrMapOvr>
-</p:sld>
-</file>
-
-<file path=ppt/slides/slide8.xml><?xml version="1.0" encoding="utf-8"?>
-<p:sld xmlns:a="http://schemas.openxmlformats.org/drawingml/2006/main" xmlns:r="http://schemas.openxmlformats.org/officeDocument/2006/relationships" xmlns:p="http://schemas.openxmlformats.org/presentationml/2006/main">
-  <p:cSld name="Slide 8">
-    <p:bg>
-      <p:bgPr>
-        <a:solidFill>
-          <a:srgbClr val="F8FAFC"/>
-        </a:solidFill>
-        <a:effectLst/>
-      </p:bgPr>
-    </p:bg>
-    <p:spTree>
-      <p:nvGrpSpPr>
-        <p:cNvPr id="1" name=""/>
-        <p:cNvGrpSpPr/>
-        <p:nvPr/>
-      </p:nvGrpSpPr>
-      <p:grpSpPr>
-        <a:xfrm>
-          <a:off x="0" y="0"/>
-          <a:ext cx="0" cy="0"/>
-          <a:chOff x="0" y="0"/>
-          <a:chExt cx="0" cy="0"/>
-        </a:xfrm>
-      </p:grpSpPr>
-      <p:sp>
-        <p:nvSpPr>
-          <p:cNvPr id="2" name="Shape 0"/>
-          <p:cNvSpPr/>
-          <p:nvPr/>
-        </p:nvSpPr>
-        <p:spPr>
-          <a:xfrm>
-            <a:off x="0" y="0"/>
-            <a:ext cx="12191695" cy="146304"/>
-          </a:xfrm>
-          <a:prstGeom prst="rect">
-            <a:avLst/>
-          </a:prstGeom>
-          <a:solidFill>
-            <a:srgbClr val="1E2A5A"/>
-          </a:solidFill>
-          <a:ln w="12700">
-            <a:solidFill>
-              <a:srgbClr val="1E2A5A"/>
-            </a:solidFill>
-            <a:prstDash val="solid"/>
-          </a:ln>
-        </p:spPr>
-        <p:txBody>
-          <a:bodyPr/>
-          <a:lstStyle/>
-          <a:p>
-            <a:endParaRPr lang="tr-TR"/>
-          </a:p>
-        </p:txBody>
-      </p:sp>
-      <p:sp>
-        <p:nvSpPr>
-          <p:cNvPr id="3" name="Text 1"/>
-          <p:cNvSpPr/>
-          <p:nvPr/>
-        </p:nvSpPr>
-        <p:spPr>
-          <a:xfrm>
-            <a:off x="594360" y="438912"/>
-            <a:ext cx="8138160" cy="384048"/>
-          </a:xfrm>
-          <a:prstGeom prst="rect">
-            <a:avLst/>
-          </a:prstGeom>
-          <a:noFill/>
-          <a:ln/>
-        </p:spPr>
-        <p:txBody>
-          <a:bodyPr wrap="square" lIns="0" tIns="0" rIns="0" bIns="0" rtlCol="0" anchor="ctr"/>
-          <a:lstStyle/>
-          <a:p>
-            <a:pPr marL="0" indent="0">
-              <a:buNone/>
-            </a:pPr>
-            <a:r>
-              <a:rPr lang="en-US" sz="2400" b="1" dirty="0">
-                <a:solidFill>
-                  <a:srgbClr val="1E2A5A"/>
-                </a:solidFill>
-                <a:latin typeface="Aptos Display" pitchFamily="34" charset="0"/>
-                <a:ea typeface="Aptos Display" pitchFamily="34" charset="-122"/>
-                <a:cs typeface="Aptos Display" pitchFamily="34" charset="-120"/>
-              </a:rPr>
-              <a:t>7. Literatürle İlişki</a:t>
-            </a:r>
-            <a:endParaRPr lang="en-US" sz="2400" dirty="0"/>
-          </a:p>
-        </p:txBody>
-      </p:sp>
-      <p:sp>
-        <p:nvSpPr>
-          <p:cNvPr id="4" name="Text 2"/>
-          <p:cNvSpPr/>
-          <p:nvPr/>
-        </p:nvSpPr>
-        <p:spPr>
-          <a:xfrm>
-            <a:off x="612648" y="896112"/>
-            <a:ext cx="9966960" cy="256032"/>
-          </a:xfrm>
-          <a:prstGeom prst="rect">
-            <a:avLst/>
-          </a:prstGeom>
-          <a:noFill/>
-          <a:ln/>
-        </p:spPr>
-        <p:txBody>
-          <a:bodyPr wrap="square" lIns="0" tIns="0" rIns="0" bIns="0" rtlCol="0" anchor="ctr"/>
-          <a:lstStyle/>
-          <a:p>
-            <a:pPr marL="0" indent="0">
-              <a:buNone/>
-            </a:pPr>
-            <a:r>
-              <a:rPr lang="en-US" sz="1050" i="1" dirty="0">
-                <a:solidFill>
-                  <a:srgbClr val="6B7280"/>
-                </a:solidFill>
-                <a:latin typeface="Aptos" pitchFamily="34" charset="0"/>
-                <a:ea typeface="Aptos" pitchFamily="34" charset="-122"/>
-                <a:cs typeface="Aptos" pitchFamily="34" charset="-120"/>
-              </a:rPr>
-              <a:t>Kendi sonucunuzu literatür içinde konumlandırın.</a:t>
-            </a:r>
-            <a:endParaRPr lang="en-US" sz="1050" dirty="0"/>
-          </a:p>
-        </p:txBody>
-      </p:sp>
-      <p:sp>
-        <p:nvSpPr>
-          <p:cNvPr id="5" name="Shape 3"/>
-          <p:cNvSpPr/>
-          <p:nvPr/>
-        </p:nvSpPr>
-        <p:spPr>
-          <a:xfrm>
-            <a:off x="594360" y="1261872"/>
-            <a:ext cx="10972800" cy="0"/>
-          </a:xfrm>
-          <a:prstGeom prst="line">
-            <a:avLst/>
-          </a:prstGeom>
-          <a:noFill/>
-          <a:ln w="9525">
-            <a:solidFill>
-              <a:srgbClr val="CBD5E1"/>
-            </a:solidFill>
-            <a:prstDash val="solid"/>
-          </a:ln>
-        </p:spPr>
-        <p:txBody>
-          <a:bodyPr/>
-          <a:lstStyle/>
-          <a:p>
-            <a:endParaRPr lang="tr-TR"/>
-          </a:p>
-        </p:txBody>
-      </p:sp>
-      <p:sp>
-        <p:nvSpPr>
-          <p:cNvPr id="6" name="Text 4"/>
-          <p:cNvSpPr/>
-          <p:nvPr/>
-        </p:nvSpPr>
-        <p:spPr>
-          <a:xfrm>
-            <a:off x="594360" y="6510528"/>
-            <a:ext cx="5029200" cy="201168"/>
-          </a:xfrm>
-          <a:prstGeom prst="rect">
-            <a:avLst/>
-          </a:prstGeom>
-          <a:noFill/>
-          <a:ln/>
-        </p:spPr>
-        <p:txBody>
-          <a:bodyPr wrap="square" lIns="0" tIns="0" rIns="0" bIns="0" rtlCol="0" anchor="ctr"/>
-          <a:lstStyle/>
-          <a:p>
-            <a:pPr marL="0" indent="0">
-              <a:buNone/>
-            </a:pPr>
-            <a:r>
-              <a:rPr lang="en-US" sz="850" dirty="0">
-                <a:solidFill>
-                  <a:srgbClr val="6B7280"/>
-                </a:solidFill>
-                <a:latin typeface="Aptos" pitchFamily="34" charset="0"/>
-                <a:ea typeface="Aptos" pitchFamily="34" charset="-122"/>
-                <a:cs typeface="Aptos" pitchFamily="34" charset="-120"/>
-              </a:rPr>
-              <a:t>Final Makale/Bildiri Sunumu  •  8/10</a:t>
-            </a:r>
-            <a:endParaRPr lang="en-US" sz="850" dirty="0"/>
-          </a:p>
-        </p:txBody>
-      </p:sp>
-      <p:sp>
-        <p:nvSpPr>
-          <p:cNvPr id="7" name="Text 5"/>
-          <p:cNvSpPr/>
-          <p:nvPr/>
-        </p:nvSpPr>
-        <p:spPr>
-          <a:xfrm>
-            <a:off x="6995160" y="6510528"/>
-            <a:ext cx="4572000" cy="201168"/>
-          </a:xfrm>
-          <a:prstGeom prst="rect">
-            <a:avLst/>
-          </a:prstGeom>
-          <a:noFill/>
-          <a:ln/>
-        </p:spPr>
-        <p:txBody>
-          <a:bodyPr wrap="square" lIns="0" tIns="0" rIns="0" bIns="0" rtlCol="0" anchor="ctr"/>
-          <a:lstStyle/>
-          <a:p>
-            <a:pPr marL="0" indent="0" algn="r">
-              <a:buNone/>
-            </a:pPr>
-            <a:r>
-              <a:rPr lang="en-US" sz="850" dirty="0">
-                <a:solidFill>
-                  <a:srgbClr val="6B7280"/>
-                </a:solidFill>
-                <a:latin typeface="Aptos" pitchFamily="34" charset="0"/>
-                <a:ea typeface="Aptos" pitchFamily="34" charset="-122"/>
-                <a:cs typeface="Aptos" pitchFamily="34" charset="-120"/>
-              </a:rPr>
-              <a:t>İleri Bilgisayarlı Görme ve Derin Öğrenme</a:t>
-            </a:r>
-            <a:endParaRPr lang="en-US" sz="850" dirty="0"/>
-          </a:p>
-        </p:txBody>
-      </p:sp>
-      <p:sp>
-        <p:nvSpPr>
-          <p:cNvPr id="8" name="Text 6"/>
-          <p:cNvSpPr/>
-          <p:nvPr/>
-        </p:nvSpPr>
-        <p:spPr>
-          <a:xfrm>
-            <a:off x="749808" y="1600200"/>
-            <a:ext cx="10378440" cy="3200400"/>
-          </a:xfrm>
-          <a:prstGeom prst="rect">
-            <a:avLst/>
-          </a:prstGeom>
-          <a:noFill/>
-          <a:ln/>
-        </p:spPr>
-        <p:txBody>
-          <a:bodyPr wrap="square" lIns="254" tIns="254" rIns="254" bIns="254" rtlCol="0" anchor="ctr">
-            <a:normAutofit/>
-          </a:bodyPr>
-          <a:lstStyle/>
-          <a:p>
-            <a:r>
-              <a:rPr lang="en-US" sz="1550" dirty="0">
-                <a:solidFill>
-                  <a:srgbClr val="111827"/>
-                </a:solidFill>
-                <a:latin typeface="Aptos" pitchFamily="34" charset="0"/>
-                <a:ea typeface="Aptos" pitchFamily="34" charset="-122"/>
-                <a:cs typeface="Aptos" pitchFamily="34" charset="-120"/>
-              </a:rPr>
-              <a:t>Mümkünse aynı veri kümesi, değilse aynı problem alanındaki benzer çalışmalarla kısa karşılaştırma.</a:t>
-            </a:r>
-            <a:endParaRPr lang="en-US" sz="1550" dirty="0"/>
-          </a:p>
-          <a:p>
-            <a:r>
-              <a:rPr lang="en-US" sz="1550" dirty="0">
-                <a:solidFill>
-                  <a:srgbClr val="111827"/>
-                </a:solidFill>
-                <a:latin typeface="Aptos" pitchFamily="34" charset="0"/>
-                <a:ea typeface="Aptos" pitchFamily="34" charset="-122"/>
-                <a:cs typeface="Aptos" pitchFamily="34" charset="-120"/>
-              </a:rPr>
-              <a:t>Karşılaştırmada yöntem, metrik, veri bölünmesi ve deney koşullarının farklı olabileceğini belirtme.</a:t>
-            </a:r>
-            <a:endParaRPr lang="en-US" sz="1550" dirty="0"/>
-          </a:p>
-          <a:p>
-            <a:r>
-              <a:rPr lang="en-US" sz="1550" dirty="0">
-                <a:solidFill>
-                  <a:srgbClr val="111827"/>
-                </a:solidFill>
-                <a:latin typeface="Aptos" pitchFamily="34" charset="0"/>
-                <a:ea typeface="Aptos" pitchFamily="34" charset="-122"/>
-                <a:cs typeface="Aptos" pitchFamily="34" charset="-120"/>
-              </a:rPr>
-              <a:t>Literatürdeki sonuçları geçme zorunluluğu yoktur; amaç kendi sonucunuzu bağlam içinde değerlendirmektir.</a:t>
-            </a:r>
-            <a:endParaRPr lang="en-US" sz="1550" dirty="0"/>
-          </a:p>
-          <a:p>
-            <a:r>
-              <a:rPr lang="en-US" sz="1550" dirty="0">
-                <a:solidFill>
-                  <a:srgbClr val="111827"/>
-                </a:solidFill>
-                <a:latin typeface="Aptos" pitchFamily="34" charset="0"/>
-                <a:ea typeface="Aptos" pitchFamily="34" charset="-122"/>
-                <a:cs typeface="Aptos" pitchFamily="34" charset="-120"/>
-              </a:rPr>
-              <a:t>Bu bölüm tablo halinde ya da kısa anlatı şeklinde sunulabilir.</a:t>
-            </a:r>
-            <a:endParaRPr lang="en-US" sz="1550" dirty="0"/>
-          </a:p>
-        </p:txBody>
-      </p:sp>
-      <p:sp>
-        <p:nvSpPr>
-          <p:cNvPr id="9" name="Shape 7"/>
-          <p:cNvSpPr/>
-          <p:nvPr/>
-        </p:nvSpPr>
-        <p:spPr>
-          <a:xfrm>
-            <a:off x="749808" y="5074920"/>
-            <a:ext cx="10378440" cy="713232"/>
-          </a:xfrm>
-          <a:prstGeom prst="rect">
-            <a:avLst/>
-          </a:prstGeom>
-          <a:solidFill>
-            <a:srgbClr val="EEF2F7"/>
-          </a:solidFill>
-          <a:ln w="12700">
-            <a:solidFill>
-              <a:srgbClr val="CBD5E1">
-                <a:alpha val="80000"/>
-              </a:srgbClr>
-            </a:solidFill>
-            <a:prstDash val="solid"/>
-          </a:ln>
-        </p:spPr>
-        <p:txBody>
-          <a:bodyPr/>
-          <a:lstStyle/>
-          <a:p>
-            <a:endParaRPr lang="tr-TR"/>
-          </a:p>
-        </p:txBody>
-      </p:sp>
-      <p:sp>
-        <p:nvSpPr>
-          <p:cNvPr id="10" name="Text 8"/>
-          <p:cNvSpPr/>
-          <p:nvPr/>
-        </p:nvSpPr>
-        <p:spPr>
-          <a:xfrm>
-            <a:off x="987552" y="5248656"/>
-            <a:ext cx="9921240" cy="347472"/>
-          </a:xfrm>
-          <a:prstGeom prst="rect">
-            <a:avLst/>
-          </a:prstGeom>
-          <a:noFill/>
-          <a:ln/>
-        </p:spPr>
-        <p:txBody>
-          <a:bodyPr wrap="square" lIns="127" tIns="127" rIns="127" bIns="127" rtlCol="0" anchor="ctr">
-            <a:normAutofit/>
-          </a:bodyPr>
-          <a:lstStyle/>
-          <a:p>
-            <a:pPr marL="0" indent="0">
-              <a:buNone/>
-            </a:pPr>
-            <a:r>
-              <a:rPr lang="en-US" sz="1200" i="1" dirty="0">
-                <a:solidFill>
-                  <a:srgbClr val="1E2A5A"/>
-                </a:solidFill>
-                <a:latin typeface="Aptos" pitchFamily="34" charset="0"/>
-                <a:ea typeface="Aptos" pitchFamily="34" charset="-122"/>
-                <a:cs typeface="Aptos" pitchFamily="34" charset="-120"/>
-              </a:rPr>
-              <a:t>Makaledeki literatür ve tartışma bölümlerinizden seçilmiş kısa bir özet yeterlidir.</a:t>
-            </a:r>
-            <a:endParaRPr lang="en-US" sz="1200" dirty="0"/>
-          </a:p>
-        </p:txBody>
-      </p:sp>
-    </p:spTree>
-  </p:cSld>
-  <p:clrMapOvr>
-    <a:masterClrMapping/>
-  </p:clrMapOvr>
-</p:sld>
-</file>
-
-<file path=ppt/slides/slide9.xml><?xml version="1.0" encoding="utf-8"?>
-<p:sld xmlns:a="http://schemas.openxmlformats.org/drawingml/2006/main" xmlns:r="http://schemas.openxmlformats.org/officeDocument/2006/relationships" xmlns:p="http://schemas.openxmlformats.org/presentationml/2006/main">
-  <p:cSld name="Slide 9">
-    <p:bg>
-      <p:bgPr>
-        <a:solidFill>
-          <a:srgbClr val="F8FAFC"/>
-        </a:solidFill>
-        <a:effectLst/>
-      </p:bgPr>
-    </p:bg>
-    <p:spTree>
-      <p:nvGrpSpPr>
-        <p:cNvPr id="1" name=""/>
-        <p:cNvGrpSpPr/>
-        <p:nvPr/>
-      </p:nvGrpSpPr>
-      <p:grpSpPr>
-        <a:xfrm>
-          <a:off x="0" y="0"/>
-          <a:ext cx="0" cy="0"/>
-          <a:chOff x="0" y="0"/>
-          <a:chExt cx="0" cy="0"/>
-        </a:xfrm>
-      </p:grpSpPr>
-      <p:sp>
-        <p:nvSpPr>
-          <p:cNvPr id="2" name="Shape 0"/>
-          <p:cNvSpPr/>
-          <p:nvPr/>
-        </p:nvSpPr>
-        <p:spPr>
-          <a:xfrm>
-            <a:off x="0" y="0"/>
-            <a:ext cx="12191695" cy="146304"/>
-          </a:xfrm>
-          <a:prstGeom prst="rect">
-            <a:avLst/>
-          </a:prstGeom>
-          <a:solidFill>
-            <a:srgbClr val="1E2A5A"/>
-          </a:solidFill>
-          <a:ln w="12700">
-            <a:solidFill>
-              <a:srgbClr val="1E2A5A"/>
-            </a:solidFill>
-            <a:prstDash val="solid"/>
-          </a:ln>
-        </p:spPr>
-        <p:txBody>
-          <a:bodyPr/>
-          <a:lstStyle/>
-          <a:p>
-            <a:endParaRPr lang="tr-TR"/>
-          </a:p>
-        </p:txBody>
-      </p:sp>
-      <p:sp>
-        <p:nvSpPr>
-          <p:cNvPr id="3" name="Text 1"/>
-          <p:cNvSpPr/>
-          <p:nvPr/>
-        </p:nvSpPr>
-        <p:spPr>
-          <a:xfrm>
-            <a:off x="594360" y="438912"/>
-            <a:ext cx="8138160" cy="384048"/>
-          </a:xfrm>
-          <a:prstGeom prst="rect">
-            <a:avLst/>
-          </a:prstGeom>
-          <a:noFill/>
-          <a:ln/>
-        </p:spPr>
-        <p:txBody>
-          <a:bodyPr wrap="square" lIns="0" tIns="0" rIns="0" bIns="0" rtlCol="0" anchor="ctr"/>
-          <a:lstStyle/>
-          <a:p>
-            <a:pPr marL="0" indent="0">
-              <a:buNone/>
-            </a:pPr>
-            <a:r>
-              <a:rPr lang="en-US" sz="2400" b="1" dirty="0">
-                <a:solidFill>
-                  <a:srgbClr val="1E2A5A"/>
-                </a:solidFill>
-                <a:latin typeface="Aptos Display" pitchFamily="34" charset="0"/>
-                <a:ea typeface="Aptos Display" pitchFamily="34" charset="-122"/>
-                <a:cs typeface="Aptos Display" pitchFamily="34" charset="-120"/>
-              </a:rPr>
-              <a:t>8. Tartışma ve Sınırlılıklar</a:t>
-            </a:r>
-            <a:endParaRPr lang="en-US" sz="2400" dirty="0"/>
-          </a:p>
-        </p:txBody>
-      </p:sp>
-      <p:sp>
-        <p:nvSpPr>
-          <p:cNvPr id="4" name="Text 2"/>
-          <p:cNvSpPr/>
-          <p:nvPr/>
-        </p:nvSpPr>
-        <p:spPr>
-          <a:xfrm>
-            <a:off x="612648" y="896112"/>
-            <a:ext cx="9966960" cy="256032"/>
-          </a:xfrm>
-          <a:prstGeom prst="rect">
-            <a:avLst/>
-          </a:prstGeom>
-          <a:noFill/>
-          <a:ln/>
-        </p:spPr>
-        <p:txBody>
-          <a:bodyPr wrap="square" lIns="0" tIns="0" rIns="0" bIns="0" rtlCol="0" anchor="ctr"/>
-          <a:lstStyle/>
-          <a:p>
-            <a:pPr marL="0" indent="0">
-              <a:buNone/>
-            </a:pPr>
-            <a:r>
-              <a:rPr lang="en-US" sz="1050" i="1" dirty="0">
-                <a:solidFill>
-                  <a:srgbClr val="6B7280"/>
-                </a:solidFill>
-                <a:latin typeface="Aptos" pitchFamily="34" charset="0"/>
-                <a:ea typeface="Aptos" pitchFamily="34" charset="-122"/>
-                <a:cs typeface="Aptos" pitchFamily="34" charset="-120"/>
-              </a:rPr>
-              <a:t>Çalışmanın güçlü ve sınırlı yönlerini açıkça ifade edin.</a:t>
-            </a:r>
-            <a:endParaRPr lang="en-US" sz="1050" dirty="0"/>
-          </a:p>
-        </p:txBody>
-      </p:sp>
-      <p:sp>
-        <p:nvSpPr>
-          <p:cNvPr id="5" name="Shape 3"/>
-          <p:cNvSpPr/>
-          <p:nvPr/>
-        </p:nvSpPr>
-        <p:spPr>
-          <a:xfrm>
-            <a:off x="594360" y="1261872"/>
-            <a:ext cx="10972800" cy="0"/>
-          </a:xfrm>
-          <a:prstGeom prst="line">
-            <a:avLst/>
-          </a:prstGeom>
-          <a:noFill/>
-          <a:ln w="9525">
-            <a:solidFill>
-              <a:srgbClr val="CBD5E1"/>
-            </a:solidFill>
-            <a:prstDash val="solid"/>
-          </a:ln>
-        </p:spPr>
-        <p:txBody>
-          <a:bodyPr/>
-          <a:lstStyle/>
-          <a:p>
-            <a:endParaRPr lang="tr-TR"/>
-          </a:p>
-        </p:txBody>
-      </p:sp>
-      <p:sp>
-        <p:nvSpPr>
-          <p:cNvPr id="6" name="Text 4"/>
-          <p:cNvSpPr/>
-          <p:nvPr/>
-        </p:nvSpPr>
-        <p:spPr>
-          <a:xfrm>
-            <a:off x="594360" y="6510528"/>
-            <a:ext cx="5029200" cy="201168"/>
-          </a:xfrm>
-          <a:prstGeom prst="rect">
-            <a:avLst/>
-          </a:prstGeom>
-          <a:noFill/>
-          <a:ln/>
-        </p:spPr>
-        <p:txBody>
-          <a:bodyPr wrap="square" lIns="0" tIns="0" rIns="0" bIns="0" rtlCol="0" anchor="ctr"/>
-          <a:lstStyle/>
-          <a:p>
-            <a:pPr marL="0" indent="0">
-              <a:buNone/>
-            </a:pPr>
-            <a:r>
-              <a:rPr lang="en-US" sz="850" dirty="0">
-                <a:solidFill>
-                  <a:srgbClr val="6B7280"/>
-                </a:solidFill>
-                <a:latin typeface="Aptos" pitchFamily="34" charset="0"/>
-                <a:ea typeface="Aptos" pitchFamily="34" charset="-122"/>
-                <a:cs typeface="Aptos" pitchFamily="34" charset="-120"/>
-              </a:rPr>
-              <a:t>Final Makale/Bildiri Sunumu  •  9/10</a:t>
-            </a:r>
-            <a:endParaRPr lang="en-US" sz="850" dirty="0"/>
-          </a:p>
-        </p:txBody>
-      </p:sp>
-      <p:sp>
-        <p:nvSpPr>
-          <p:cNvPr id="7" name="Text 5"/>
-          <p:cNvSpPr/>
-          <p:nvPr/>
-        </p:nvSpPr>
-        <p:spPr>
-          <a:xfrm>
-            <a:off x="6995160" y="6510528"/>
-            <a:ext cx="4572000" cy="201168"/>
-          </a:xfrm>
-          <a:prstGeom prst="rect">
-            <a:avLst/>
-          </a:prstGeom>
-          <a:noFill/>
-          <a:ln/>
-        </p:spPr>
-        <p:txBody>
-          <a:bodyPr wrap="square" lIns="0" tIns="0" rIns="0" bIns="0" rtlCol="0" anchor="ctr"/>
-          <a:lstStyle/>
-          <a:p>
-            <a:pPr marL="0" indent="0" algn="r">
-              <a:buNone/>
-            </a:pPr>
-            <a:r>
-              <a:rPr lang="en-US" sz="850" dirty="0">
-                <a:solidFill>
-                  <a:srgbClr val="6B7280"/>
-                </a:solidFill>
-                <a:latin typeface="Aptos" pitchFamily="34" charset="0"/>
-                <a:ea typeface="Aptos" pitchFamily="34" charset="-122"/>
-                <a:cs typeface="Aptos" pitchFamily="34" charset="-120"/>
-              </a:rPr>
-              <a:t>İleri Bilgisayarlı Görme ve Derin Öğrenme</a:t>
-            </a:r>
-            <a:endParaRPr lang="en-US" sz="850" dirty="0"/>
-          </a:p>
-        </p:txBody>
-      </p:sp>
-      <p:sp>
-        <p:nvSpPr>
-          <p:cNvPr id="8" name="Text 6"/>
-          <p:cNvSpPr/>
-          <p:nvPr/>
-        </p:nvSpPr>
-        <p:spPr>
-          <a:xfrm>
-            <a:off x="749808" y="1600200"/>
-            <a:ext cx="10378440" cy="3200400"/>
-          </a:xfrm>
-          <a:prstGeom prst="rect">
-            <a:avLst/>
-          </a:prstGeom>
-          <a:noFill/>
-          <a:ln/>
-        </p:spPr>
-        <p:txBody>
-          <a:bodyPr wrap="square" lIns="254" tIns="254" rIns="254" bIns="254" rtlCol="0" anchor="ctr">
-            <a:normAutofit/>
-          </a:bodyPr>
-          <a:lstStyle/>
-          <a:p>
-            <a:r>
-              <a:rPr lang="en-US" sz="1550" dirty="0">
-                <a:solidFill>
-                  <a:srgbClr val="111827"/>
-                </a:solidFill>
-                <a:latin typeface="Aptos" pitchFamily="34" charset="0"/>
-                <a:ea typeface="Aptos" pitchFamily="34" charset="-122"/>
-                <a:cs typeface="Aptos" pitchFamily="34" charset="-120"/>
-              </a:rPr>
-              <a:t>Elde edilen bulguların genel yorumu.</a:t>
-            </a:r>
-            <a:endParaRPr lang="en-US" sz="1550" dirty="0"/>
-          </a:p>
-          <a:p>
-            <a:r>
-              <a:rPr lang="en-US" sz="1550" dirty="0">
-                <a:solidFill>
-                  <a:srgbClr val="111827"/>
-                </a:solidFill>
-                <a:latin typeface="Aptos" pitchFamily="34" charset="0"/>
-                <a:ea typeface="Aptos" pitchFamily="34" charset="-122"/>
-                <a:cs typeface="Aptos" pitchFamily="34" charset="-120"/>
-              </a:rPr>
-              <a:t>Çalışmanın güçlü yönü: ne iyi yapıldı, ne gösterildi?</a:t>
-            </a:r>
-            <a:endParaRPr lang="en-US" sz="1550" dirty="0"/>
-          </a:p>
-          <a:p>
-            <a:r>
-              <a:rPr lang="en-US" sz="1550" dirty="0">
-                <a:solidFill>
-                  <a:srgbClr val="111827"/>
-                </a:solidFill>
-                <a:latin typeface="Aptos" pitchFamily="34" charset="0"/>
-                <a:ea typeface="Aptos" pitchFamily="34" charset="-122"/>
-                <a:cs typeface="Aptos" pitchFamily="34" charset="-120"/>
-              </a:rPr>
-              <a:t>Sınırlılıklar: veri, model, compute, metrik, tek seed, split farkı vb.</a:t>
-            </a:r>
-            <a:endParaRPr lang="en-US" sz="1550" dirty="0"/>
-          </a:p>
-          <a:p>
-            <a:r>
-              <a:rPr lang="en-US" sz="1550" dirty="0">
-                <a:solidFill>
-                  <a:srgbClr val="111827"/>
-                </a:solidFill>
-                <a:latin typeface="Aptos" pitchFamily="34" charset="0"/>
-                <a:ea typeface="Aptos" pitchFamily="34" charset="-122"/>
-                <a:cs typeface="Aptos" pitchFamily="34" charset="-120"/>
-              </a:rPr>
-              <a:t>Bu sınırlılıklar sonuçların yorumunu nasıl etkiliyor?</a:t>
-            </a:r>
-            <a:endParaRPr lang="en-US" sz="1550" dirty="0"/>
-          </a:p>
-        </p:txBody>
-      </p:sp>
-      <p:sp>
-        <p:nvSpPr>
-          <p:cNvPr id="9" name="Shape 7"/>
-          <p:cNvSpPr/>
-          <p:nvPr/>
-        </p:nvSpPr>
-        <p:spPr>
-          <a:xfrm>
-            <a:off x="749808" y="5074920"/>
-            <a:ext cx="10378440" cy="713232"/>
-          </a:xfrm>
-          <a:prstGeom prst="rect">
-            <a:avLst/>
-          </a:prstGeom>
-          <a:solidFill>
-            <a:srgbClr val="EEF2F7"/>
-          </a:solidFill>
-          <a:ln w="12700">
-            <a:solidFill>
-              <a:srgbClr val="CBD5E1">
-                <a:alpha val="80000"/>
-              </a:srgbClr>
-            </a:solidFill>
-            <a:prstDash val="solid"/>
-          </a:ln>
-        </p:spPr>
-        <p:txBody>
-          <a:bodyPr/>
-          <a:lstStyle/>
-          <a:p>
-            <a:endParaRPr lang="tr-TR"/>
-          </a:p>
-        </p:txBody>
-      </p:sp>
-      <p:sp>
-        <p:nvSpPr>
-          <p:cNvPr id="10" name="Text 8"/>
-          <p:cNvSpPr/>
-          <p:nvPr/>
-        </p:nvSpPr>
-        <p:spPr>
-          <a:xfrm>
-            <a:off x="987552" y="5248656"/>
-            <a:ext cx="9921240" cy="347472"/>
-          </a:xfrm>
-          <a:prstGeom prst="rect">
-            <a:avLst/>
-          </a:prstGeom>
-          <a:noFill/>
-          <a:ln/>
-        </p:spPr>
-        <p:txBody>
-          <a:bodyPr wrap="square" lIns="127" tIns="127" rIns="127" bIns="127" rtlCol="0" anchor="ctr">
-            <a:normAutofit/>
-          </a:bodyPr>
-          <a:lstStyle/>
-          <a:p>
-            <a:pPr marL="0" indent="0">
-              <a:buNone/>
-            </a:pPr>
-            <a:r>
-              <a:rPr lang="en-US" sz="1200" i="1" dirty="0">
-                <a:solidFill>
-                  <a:srgbClr val="1E2A5A"/>
-                </a:solidFill>
-                <a:latin typeface="Aptos" pitchFamily="34" charset="0"/>
-                <a:ea typeface="Aptos" pitchFamily="34" charset="-122"/>
-                <a:cs typeface="Aptos" pitchFamily="34" charset="-120"/>
-              </a:rPr>
-              <a:t>Sınırlılık yazmak çalışmayı zayıflatmaz; aksine akademik olgunluk gösterir.</a:t>
             </a:r>
             <a:endParaRPr lang="en-US" sz="1200" dirty="0"/>
           </a:p>

</xml_diff>